<commit_message>
Fix README, .env.example, .gitignore, and update PPTX slides
- README: correct env vars to Azure/Groq, fix .env path to backend/.env, remove Python prerequisite
- .env.example: replace OpenAI with actual Azure OpenAI + Groq + AssemblyAI vars
- .gitignore: add docs/unpacked/ and *.docx exclusions
- PPTX slides 2,3,5: reflect actual tech stack (Groq not GPT-4o-mini, AssemblyAI diarization built)

Co-Authored-By: Claude Sonnet 4.6 <noreply@anthropic.com>
</commit_message>
<xml_diff>
--- a/docs/SyncBoard_MVP_Technical_Summary.pptx
+++ b/docs/SyncBoard_MVP_Technical_Summary.pptx
@@ -4,6 +4,9 @@
   <p:sldMasterIdLst>
     <p:sldMasterId id="2147483648" r:id="rId1"/>
   </p:sldMasterIdLst>
+  <p:notesMasterIdLst>
+    <p:notesMasterId r:id="rId7"/>
+  </p:notesMasterIdLst>
   <p:sldIdLst>
     <p:sldId id="256" r:id="rId2"/>
     <p:sldId id="257" r:id="rId3"/>
@@ -11,10 +14,7 @@
     <p:sldId id="259" r:id="rId5"/>
     <p:sldId id="260" r:id="rId6"/>
   </p:sldIdLst>
-  <p:notesMasterIdLst>
-    <p:notesMasterId r:id="rId7"/>
-  </p:notesMasterIdLst>
-  <p:sldSz cx="9144000" cy="5143500"/>
+  <p:sldSz cx="9144000" cy="5143500" type="screen16x9"/>
   <p:notesSz cx="5143500" cy="9144000"/>
   <p:defaultTextStyle>
     <a:lvl1pPr marL="0" algn="l" defTabSz="914400" rtl="0" eaLnBrk="1" latinLnBrk="0" hangingPunct="1">
@@ -108,6 +108,11 @@
       </a:defRPr>
     </a:lvl9pPr>
   </p:defaultTextStyle>
+  <p:extLst>
+    <p:ext uri="{EFAFB233-063F-42B5-8137-9DF3F51BA10A}">
+      <p15:sldGuideLst xmlns:p15="http://schemas.microsoft.com/office/powerpoint/2012/main"/>
+    </p:ext>
+  </p:extLst>
 </p:presentation>
 </file>
 
@@ -133,234 +138,10 @@
           <a:chExt cx="0" cy="0"/>
         </a:xfrm>
       </p:grpSpPr>
-      <p:sp>
-        <p:nvSpPr>
-          <p:cNvPr id="2" name="Header Placeholder 1"/>
-          <p:cNvSpPr>
-            <a:spLocks noGrp="1"/>
-          </p:cNvSpPr>
-          <p:nvPr>
-            <p:ph type="hdr" sz="quarter"/>
-          </p:nvPr>
-        </p:nvSpPr>
-        <p:spPr>
-          <a:xfrm>
-            <a:off x="0" y="0"/>
-            <a:ext cx="2971800" cy="458788"/>
-          </a:xfrm>
-          <a:prstGeom prst="rect">
-            <a:avLst/>
-          </a:prstGeom>
-        </p:spPr>
-        <p:txBody>
-          <a:bodyPr vert="horz" lIns="91440" tIns="45720" rIns="91440" bIns="45720" rtlCol="0"/>
-          <a:lstStyle>
-            <a:lvl1pPr algn="l">
-              <a:defRPr sz="1200"/>
-            </a:lvl1pPr>
-          </a:lstStyle>
-          <a:p>
-            <a:endParaRPr lang="en-US"/>
-          </a:p>
-        </p:txBody>
-      </p:sp>
-      <p:sp>
-        <p:nvSpPr>
-          <p:cNvPr id="3" name="Date Placeholder 2"/>
-          <p:cNvSpPr>
-            <a:spLocks noGrp="1"/>
-          </p:cNvSpPr>
-          <p:nvPr>
-            <p:ph type="dt" idx="1"/>
-          </p:nvPr>
-        </p:nvSpPr>
-        <p:spPr>
-          <a:xfrm>
-            <a:off x="3884613" y="0"/>
-            <a:ext cx="2971800" cy="458788"/>
-          </a:xfrm>
-          <a:prstGeom prst="rect">
-            <a:avLst/>
-          </a:prstGeom>
-        </p:spPr>
-        <p:txBody>
-          <a:bodyPr vert="horz" lIns="91440" tIns="45720" rIns="91440" bIns="45720" rtlCol="0"/>
-          <a:lstStyle>
-            <a:lvl1pPr algn="r">
-              <a:defRPr sz="1200"/>
-            </a:lvl1pPr>
-          </a:lstStyle>
-          <a:p>
-            <a:fld id="{5282F153-3F37-0F45-9E97-73ACFA13230C}" type="datetimeFigureOut">
-              <a:rPr lang="en-US"/>
-              <a:t>7/23/19</a:t>
-            </a:fld>
-            <a:endParaRPr lang="en-US"/>
-          </a:p>
-        </p:txBody>
-      </p:sp>
-      <p:sp>
-        <p:nvSpPr>
-          <p:cNvPr id="4" name="Slide Image Placeholder 3"/>
-          <p:cNvSpPr>
-            <a:spLocks noGrp="1" noRot="1" noChangeAspect="1"/>
-          </p:cNvSpPr>
-          <p:nvPr>
-            <p:ph type="sldImg" idx="2"/>
-          </p:nvPr>
-        </p:nvSpPr>
-        <p:spPr>
-          <a:xfrm>
-            <a:off x="685800" y="1143000"/>
-            <a:ext cx="5486400" cy="3086100"/>
-          </a:xfrm>
-          <a:prstGeom prst="rect">
-            <a:avLst/>
-          </a:prstGeom>
-          <a:noFill/>
-          <a:ln w="12700">
-            <a:solidFill>
-              <a:prstClr val="black"/>
-            </a:solidFill>
-          </a:ln>
-        </p:spPr>
-        <p:txBody>
-          <a:bodyPr vert="horz" lIns="91440" tIns="45720" rIns="91440" bIns="45720" rtlCol="0" anchor="ctr"/>
-          <a:lstStyle/>
-          <a:p>
-            <a:endParaRPr lang="en-US"/>
-          </a:p>
-        </p:txBody>
-      </p:sp>
-      <p:sp>
-        <p:nvSpPr>
-          <p:cNvPr id="5" name="Notes Placeholder 4"/>
-          <p:cNvSpPr>
-            <a:spLocks noGrp="1"/>
-          </p:cNvSpPr>
-          <p:nvPr>
-            <p:ph type="body" sz="quarter" idx="3"/>
-          </p:nvPr>
-        </p:nvSpPr>
-        <p:spPr>
-          <a:xfrm>
-            <a:off x="685800" y="4400550"/>
-            <a:ext cx="5486400" cy="3600450"/>
-          </a:xfrm>
-          <a:prstGeom prst="rect">
-            <a:avLst/>
-          </a:prstGeom>
-        </p:spPr>
-        <p:txBody>
-          <a:bodyPr vert="horz" lIns="91440" tIns="45720" rIns="91440" bIns="45720" rtlCol="0"/>
-          <a:lstStyle/>
-          <a:p>
-            <a:pPr lvl="0"/>
-            <a:r>
-              <a:rPr lang="en-US"/>
-              <a:t>Click to edit Master text styles</a:t>
-            </a:r>
-          </a:p>
-          <a:p>
-            <a:pPr lvl="1"/>
-            <a:r>
-              <a:rPr lang="en-US"/>
-              <a:t>Second level</a:t>
-            </a:r>
-          </a:p>
-          <a:p>
-            <a:pPr lvl="2"/>
-            <a:r>
-              <a:rPr lang="en-US"/>
-              <a:t>Third level</a:t>
-            </a:r>
-          </a:p>
-          <a:p>
-            <a:pPr lvl="3"/>
-            <a:r>
-              <a:rPr lang="en-US"/>
-              <a:t>Fourth level</a:t>
-            </a:r>
-          </a:p>
-          <a:p>
-            <a:pPr lvl="4"/>
-            <a:r>
-              <a:rPr lang="en-US"/>
-              <a:t>Fifth level</a:t>
-            </a:r>
-          </a:p>
-        </p:txBody>
-      </p:sp>
-      <p:sp>
-        <p:nvSpPr>
-          <p:cNvPr id="6" name="Footer Placeholder 5"/>
-          <p:cNvSpPr>
-            <a:spLocks noGrp="1"/>
-          </p:cNvSpPr>
-          <p:nvPr>
-            <p:ph type="ftr" sz="quarter" idx="4"/>
-          </p:nvPr>
-        </p:nvSpPr>
-        <p:spPr>
-          <a:xfrm>
-            <a:off x="0" y="8685213"/>
-            <a:ext cx="2971800" cy="458787"/>
-          </a:xfrm>
-          <a:prstGeom prst="rect">
-            <a:avLst/>
-          </a:prstGeom>
-        </p:spPr>
-        <p:txBody>
-          <a:bodyPr vert="horz" lIns="91440" tIns="45720" rIns="91440" bIns="45720" rtlCol="0" anchor="b"/>
-          <a:lstStyle>
-            <a:lvl1pPr algn="l">
-              <a:defRPr sz="1200"/>
-            </a:lvl1pPr>
-          </a:lstStyle>
-          <a:p>
-            <a:endParaRPr lang="en-US"/>
-          </a:p>
-        </p:txBody>
-      </p:sp>
-      <p:sp>
-        <p:nvSpPr>
-          <p:cNvPr id="7" name="Slide Number Placeholder 6"/>
-          <p:cNvSpPr>
-            <a:spLocks noGrp="1"/>
-          </p:cNvSpPr>
-          <p:nvPr>
-            <p:ph type="sldNum" sz="quarter" idx="5"/>
-          </p:nvPr>
-        </p:nvSpPr>
-        <p:spPr>
-          <a:xfrm>
-            <a:off x="3884613" y="8685213"/>
-            <a:ext cx="2971800" cy="458787"/>
-          </a:xfrm>
-          <a:prstGeom prst="rect">
-            <a:avLst/>
-          </a:prstGeom>
-        </p:spPr>
-        <p:txBody>
-          <a:bodyPr vert="horz" lIns="91440" tIns="45720" rIns="91440" bIns="45720" rtlCol="0" anchor="b"/>
-          <a:lstStyle>
-            <a:lvl1pPr algn="r">
-              <a:defRPr sz="1200"/>
-            </a:lvl1pPr>
-          </a:lstStyle>
-          <a:p>
-            <a:fld id="{CE5E9CC1-C706-0F49-92D6-E571CC5EEA8F}" type="slidenum">
-              <a:rPr lang="en-US"/>
-              <a:t>‹#›</a:t>
-            </a:fld>
-            <a:endParaRPr lang="en-US"/>
-          </a:p>
-        </p:txBody>
-      </p:sp>
     </p:spTree>
     <p:extLst>
       <p:ext uri="{BB962C8B-B14F-4D97-AF65-F5344CB8AC3E}">
-        <p14:creationId xmlns:p14="http://schemas.microsoft.com/office/powerpoint/2010/main" val="1024086991"/>
+        <p14:creationId xmlns:p14="http://schemas.microsoft.com/office/powerpoint/2010/main" val="2732992081"/>
       </p:ext>
     </p:extLst>
   </p:cSld>
@@ -504,10 +285,6 @@
           <a:bodyPr/>
           <a:lstStyle/>
           <a:p>
-            <a:r>
-              <a:rPr lang="en-US" dirty="0"/>
-              <a:t/>
-            </a:r>
             <a:endParaRPr lang="en-US" dirty="0"/>
           </a:p>
         </p:txBody>
@@ -592,10 +369,6 @@
           <a:bodyPr/>
           <a:lstStyle/>
           <a:p>
-            <a:r>
-              <a:rPr lang="en-US" dirty="0"/>
-              <a:t/>
-            </a:r>
             <a:endParaRPr lang="en-US" dirty="0"/>
           </a:p>
         </p:txBody>
@@ -680,10 +453,6 @@
           <a:bodyPr/>
           <a:lstStyle/>
           <a:p>
-            <a:r>
-              <a:rPr lang="en-US" dirty="0"/>
-              <a:t/>
-            </a:r>
             <a:endParaRPr lang="en-US" dirty="0"/>
           </a:p>
         </p:txBody>
@@ -768,10 +537,6 @@
           <a:bodyPr/>
           <a:lstStyle/>
           <a:p>
-            <a:r>
-              <a:rPr lang="en-US" dirty="0"/>
-              <a:t/>
-            </a:r>
             <a:endParaRPr lang="en-US" dirty="0"/>
           </a:p>
         </p:txBody>
@@ -856,10 +621,6 @@
           <a:bodyPr/>
           <a:lstStyle/>
           <a:p>
-            <a:r>
-              <a:rPr lang="en-US" dirty="0"/>
-              <a:t/>
-            </a:r>
             <a:endParaRPr lang="en-US" dirty="0"/>
           </a:p>
         </p:txBody>
@@ -933,6 +694,11 @@
 <file path=ppt/slideMasters/slideMaster1.xml><?xml version="1.0" encoding="utf-8"?>
 <p:sldMaster xmlns:a="http://schemas.openxmlformats.org/drawingml/2006/main" xmlns:r="http://schemas.openxmlformats.org/officeDocument/2006/relationships" xmlns:p="http://schemas.openxmlformats.org/presentationml/2006/main">
   <p:cSld>
+    <p:bg>
+      <p:bgRef idx="1001">
+        <a:schemeClr val="bg1"/>
+      </p:bgRef>
+    </p:bg>
     <p:spTree>
       <p:nvGrpSpPr>
         <p:cNvPr id="1" name=""/>
@@ -1215,6 +981,7 @@
         <a:solidFill>
           <a:srgbClr val="0F172A"/>
         </a:solidFill>
+        <a:effectLst/>
       </p:bgPr>
     </p:bg>
     <p:spTree>
@@ -1239,7 +1006,7 @@
         </p:nvSpPr>
         <p:spPr>
           <a:xfrm>
-            <a:off x="457200" y="1645920"/>
+            <a:off x="457200" y="720090"/>
             <a:ext cx="8229600" cy="914400"/>
           </a:xfrm>
           <a:prstGeom prst="rect">
@@ -1252,7 +1019,7 @@
           <a:bodyPr wrap="square" rtlCol="0" anchor="ctr"/>
           <a:lstStyle/>
           <a:p>
-            <a:pPr indent="0" marL="0">
+            <a:pPr marL="0" indent="0">
               <a:buNone/>
             </a:pPr>
             <a:r>
@@ -1278,7 +1045,7 @@
         </p:nvSpPr>
         <p:spPr>
           <a:xfrm>
-            <a:off x="457200" y="2560320"/>
+            <a:off x="457200" y="1748790"/>
             <a:ext cx="8229600" cy="548640"/>
           </a:xfrm>
           <a:prstGeom prst="rect">
@@ -1291,7 +1058,7 @@
           <a:bodyPr wrap="square" rtlCol="0" anchor="ctr"/>
           <a:lstStyle/>
           <a:p>
-            <a:pPr indent="0" marL="0">
+            <a:pPr marL="0" indent="0">
               <a:buNone/>
             </a:pPr>
             <a:r>
@@ -1317,7 +1084,7 @@
         </p:nvSpPr>
         <p:spPr>
           <a:xfrm>
-            <a:off x="457200" y="3291840"/>
+            <a:off x="457200" y="2491332"/>
             <a:ext cx="8229600" cy="457200"/>
           </a:xfrm>
           <a:prstGeom prst="rect">
@@ -1330,7 +1097,7 @@
           <a:bodyPr wrap="square" rtlCol="0" anchor="ctr"/>
           <a:lstStyle/>
           <a:p>
-            <a:pPr indent="0" marL="0">
+            <a:pPr marL="0" indent="0">
               <a:buNone/>
             </a:pPr>
             <a:r>
@@ -1356,7 +1123,7 @@
         </p:nvSpPr>
         <p:spPr>
           <a:xfrm>
-            <a:off x="457200" y="4206240"/>
+            <a:off x="457200" y="3114675"/>
             <a:ext cx="8229600" cy="365760"/>
           </a:xfrm>
           <a:prstGeom prst="rect">
@@ -1369,9 +1136,6 @@
           <a:bodyPr wrap="square" rtlCol="0" anchor="ctr"/>
           <a:lstStyle/>
           <a:p>
-            <a:pPr indent="0" marL="0">
-              <a:buNone/>
-            </a:pPr>
             <a:r>
               <a:rPr lang="en-US" sz="1400" dirty="0">
                 <a:solidFill>
@@ -1381,7 +1145,7 @@
                 <a:ea typeface="Arial" pitchFamily="34" charset="-122"/>
                 <a:cs typeface="Arial" pitchFamily="34" charset="-120"/>
               </a:rPr>
-              <a:t>Hussnain (22I-1102) • Sohaib (22I-0879) • Hamdan Sajid (22I-0872)</a:t>
+              <a:t>Hussnain (22I-1102) • Sohaib (22I-0879) • Hamdan Sajid (22I-0872) • Atif Ibrahim (22I-1249)</a:t>
             </a:r>
             <a:endParaRPr lang="en-US" sz="1400" dirty="0"/>
           </a:p>
@@ -1395,7 +1159,7 @@
         </p:nvSpPr>
         <p:spPr>
           <a:xfrm>
-            <a:off x="457200" y="4572000"/>
+            <a:off x="457200" y="3617187"/>
             <a:ext cx="8229600" cy="365760"/>
           </a:xfrm>
           <a:prstGeom prst="rect">
@@ -1408,7 +1172,7 @@
           <a:bodyPr wrap="square" rtlCol="0" anchor="ctr"/>
           <a:lstStyle/>
           <a:p>
-            <a:pPr indent="0" marL="0">
+            <a:pPr marL="0" indent="0">
               <a:buNone/>
             </a:pPr>
             <a:r>
@@ -1420,7 +1184,7 @@
                 <a:ea typeface="Arial" pitchFamily="34" charset="-122"/>
                 <a:cs typeface="Arial" pitchFamily="34" charset="-120"/>
               </a:rPr>
-              <a:t>Supervisor: Ms. Urooj Ghani | FAST-NUCES | AIPD Spring 2026</a:t>
+              <a:t>FAST-NUCES | AIPD Spring 2026</a:t>
             </a:r>
             <a:endParaRPr lang="en-US" sz="1200" dirty="0"/>
           </a:p>
@@ -1445,6 +1209,13 @@
           </a:solidFill>
           <a:ln/>
         </p:spPr>
+        <p:txBody>
+          <a:bodyPr/>
+          <a:lstStyle/>
+          <a:p>
+            <a:endParaRPr lang="en-US"/>
+          </a:p>
+        </p:txBody>
       </p:sp>
     </p:spTree>
   </p:cSld>
@@ -1462,6 +1233,7 @@
         <a:solidFill>
           <a:srgbClr val="1E293B"/>
         </a:solidFill>
+        <a:effectLst/>
       </p:bgPr>
     </p:bg>
     <p:spTree>
@@ -1499,7 +1271,7 @@
           <a:bodyPr wrap="square" rtlCol="0" anchor="ctr"/>
           <a:lstStyle/>
           <a:p>
-            <a:pPr indent="0" marL="0">
+            <a:pPr marL="0" indent="0">
               <a:buNone/>
             </a:pPr>
             <a:r>
@@ -1536,6 +1308,13 @@
           </a:solidFill>
           <a:ln/>
         </p:spPr>
+        <p:txBody>
+          <a:bodyPr/>
+          <a:lstStyle/>
+          <a:p>
+            <a:endParaRPr lang="en-US"/>
+          </a:p>
+        </p:txBody>
       </p:sp>
       <p:sp>
         <p:nvSpPr>
@@ -1558,7 +1337,7 @@
           <a:bodyPr wrap="square" rtlCol="0" anchor="ctr"/>
           <a:lstStyle/>
           <a:p>
-            <a:pPr indent="0" marL="0">
+            <a:pPr marL="0" indent="0">
               <a:buNone/>
             </a:pPr>
             <a:r>
@@ -1585,7 +1364,7 @@
         <p:spPr>
           <a:xfrm>
             <a:off x="640080" y="1645920"/>
-            <a:ext cx="3657600" cy="3108960"/>
+            <a:ext cx="3657600" cy="2063931"/>
           </a:xfrm>
           <a:prstGeom prst="rect">
             <a:avLst/>
@@ -1646,7 +1425,7 @@
                 <a:ea typeface="Arial" pitchFamily="34" charset="-122"/>
                 <a:cs typeface="Arial" pitchFamily="34" charset="-120"/>
               </a:rPr>
-              <a:t>GPT-4o-mini action extraction</a:t>
+              <a:t>Groq (llama-3.3-70b) action extraction</a:t>
             </a:r>
             <a:endParaRPr lang="en-US" sz="1300" dirty="0"/>
           </a:p>
@@ -1740,6 +1519,24 @@
             </a:r>
             <a:endParaRPr lang="en-US" sz="1300" dirty="0"/>
           </a:p>
+          <a:p>
+            <a:pPr marL="342900" indent="-342900">
+              <a:buSzPct val="100000"/>
+              <a:buChar char="•"/>
+            </a:pPr>
+            <a:r>
+              <a:rPr lang="en-US" sz="1300" dirty="0">
+                <a:solidFill>
+                  <a:srgbClr val="F1F5F9"/>
+                </a:solidFill>
+                <a:latin typeface="Arial" pitchFamily="34" charset="0"/>
+                <a:ea typeface="Arial" pitchFamily="34" charset="-122"/>
+                <a:cs typeface="Arial" pitchFamily="34" charset="-120"/>
+              </a:rPr>
+              <a:t>Speaker diarization (AssemblyAI)</a:t>
+            </a:r>
+            <a:endParaRPr lang="en-US" sz="1300" dirty="0"/>
+          </a:p>
         </p:txBody>
       </p:sp>
       <p:sp>
@@ -1761,6 +1558,13 @@
           </a:solidFill>
           <a:ln/>
         </p:spPr>
+        <p:txBody>
+          <a:bodyPr/>
+          <a:lstStyle/>
+          <a:p>
+            <a:endParaRPr lang="en-US"/>
+          </a:p>
+        </p:txBody>
       </p:sp>
       <p:sp>
         <p:nvSpPr>
@@ -1783,7 +1587,7 @@
           <a:bodyPr wrap="square" rtlCol="0" anchor="ctr"/>
           <a:lstStyle/>
           <a:p>
-            <a:pPr indent="0" marL="0">
+            <a:pPr marL="0" indent="0">
               <a:buNone/>
             </a:pPr>
             <a:r>
@@ -1810,7 +1614,7 @@
         <p:spPr>
           <a:xfrm>
             <a:off x="4937760" y="1645920"/>
-            <a:ext cx="3657600" cy="3108960"/>
+            <a:ext cx="3657600" cy="1943101"/>
           </a:xfrm>
           <a:prstGeom prst="rect">
             <a:avLst/>
@@ -1871,24 +1675,6 @@
                 <a:ea typeface="Arial" pitchFamily="34" charset="-122"/>
                 <a:cs typeface="Arial" pitchFamily="34" charset="-120"/>
               </a:rPr>
-              <a:t>Speaker diarization (optional phase)</a:t>
-            </a:r>
-            <a:endParaRPr lang="en-US" sz="1300" dirty="0"/>
-          </a:p>
-          <a:p>
-            <a:pPr marL="342900" indent="-342900">
-              <a:buSzPct val="100000"/>
-              <a:buChar char="•"/>
-            </a:pPr>
-            <a:r>
-              <a:rPr lang="en-US" sz="1300" dirty="0">
-                <a:solidFill>
-                  <a:srgbClr val="F1F5F9"/>
-                </a:solidFill>
-                <a:latin typeface="Arial" pitchFamily="34" charset="0"/>
-                <a:ea typeface="Arial" pitchFamily="34" charset="-122"/>
-                <a:cs typeface="Arial" pitchFamily="34" charset="-120"/>
-              </a:rPr>
               <a:t>Custom ML models (APIs sufficient)</a:t>
             </a:r>
             <a:endParaRPr lang="en-US" sz="1300" dirty="0"/>
@@ -1965,6 +1751,7 @@
         <a:solidFill>
           <a:srgbClr val="1E293B"/>
         </a:solidFill>
+        <a:effectLst/>
       </p:bgPr>
     </p:bg>
     <p:spTree>
@@ -2002,7 +1789,7 @@
           <a:bodyPr wrap="square" rtlCol="0" anchor="ctr"/>
           <a:lstStyle/>
           <a:p>
-            <a:pPr indent="0" marL="0">
+            <a:pPr marL="0" indent="0">
               <a:buNone/>
             </a:pPr>
             <a:r>
@@ -2028,7 +1815,7 @@
         </p:nvSpPr>
         <p:spPr>
           <a:xfrm>
-            <a:off x="731520" y="2011680"/>
+            <a:off x="731520" y="1234440"/>
             <a:ext cx="1371600" cy="1097280"/>
           </a:xfrm>
           <a:prstGeom prst="rect">
@@ -2039,6 +1826,13 @@
           </a:solidFill>
           <a:ln/>
         </p:spPr>
+        <p:txBody>
+          <a:bodyPr/>
+          <a:lstStyle/>
+          <a:p>
+            <a:endParaRPr lang="en-US"/>
+          </a:p>
+        </p:txBody>
       </p:sp>
       <p:sp>
         <p:nvSpPr>
@@ -2048,7 +1842,7 @@
         </p:nvSpPr>
         <p:spPr>
           <a:xfrm>
-            <a:off x="731520" y="2103120"/>
+            <a:off x="731520" y="1325880"/>
             <a:ext cx="1371600" cy="457200"/>
           </a:xfrm>
           <a:prstGeom prst="rect">
@@ -2061,7 +1855,7 @@
           <a:bodyPr wrap="square" rtlCol="0" anchor="ctr"/>
           <a:lstStyle/>
           <a:p>
-            <a:pPr algn="ctr" indent="0" marL="0">
+            <a:pPr marL="0" indent="0" algn="ctr">
               <a:buNone/>
             </a:pPr>
             <a:r>
@@ -2084,7 +1878,7 @@
         </p:nvSpPr>
         <p:spPr>
           <a:xfrm>
-            <a:off x="731520" y="2514600"/>
+            <a:off x="731520" y="1737360"/>
             <a:ext cx="1371600" cy="548640"/>
           </a:xfrm>
           <a:prstGeom prst="rect">
@@ -2097,7 +1891,7 @@
           <a:bodyPr wrap="square" rtlCol="0" anchor="ctr"/>
           <a:lstStyle/>
           <a:p>
-            <a:pPr algn="ctr" indent="0" marL="0">
+            <a:pPr marL="0" indent="0" algn="ctr">
               <a:buNone/>
             </a:pPr>
             <a:r>
@@ -2114,7 +1908,7 @@
             <a:endParaRPr lang="en-US" sz="1100" dirty="0"/>
           </a:p>
           <a:p>
-            <a:pPr algn="ctr" indent="0" marL="0">
+            <a:pPr marL="0" indent="0" algn="ctr">
               <a:buNone/>
             </a:pPr>
             <a:r>
@@ -2140,7 +1934,7 @@
         </p:nvSpPr>
         <p:spPr>
           <a:xfrm>
-            <a:off x="2103120" y="2331720"/>
+            <a:off x="2103120" y="1554480"/>
             <a:ext cx="274320" cy="457200"/>
           </a:xfrm>
           <a:prstGeom prst="rect">
@@ -2153,7 +1947,7 @@
           <a:bodyPr wrap="square" rtlCol="0" anchor="ctr"/>
           <a:lstStyle/>
           <a:p>
-            <a:pPr algn="ctr" indent="0" marL="0">
+            <a:pPr marL="0" indent="0" algn="ctr">
               <a:buNone/>
             </a:pPr>
             <a:r>
@@ -2179,7 +1973,7 @@
         </p:nvSpPr>
         <p:spPr>
           <a:xfrm>
-            <a:off x="2377440" y="2011680"/>
+            <a:off x="2377440" y="1234440"/>
             <a:ext cx="1371600" cy="1097280"/>
           </a:xfrm>
           <a:prstGeom prst="rect">
@@ -2190,6 +1984,13 @@
           </a:solidFill>
           <a:ln/>
         </p:spPr>
+        <p:txBody>
+          <a:bodyPr/>
+          <a:lstStyle/>
+          <a:p>
+            <a:endParaRPr lang="en-US"/>
+          </a:p>
+        </p:txBody>
       </p:sp>
       <p:sp>
         <p:nvSpPr>
@@ -2199,7 +2000,7 @@
         </p:nvSpPr>
         <p:spPr>
           <a:xfrm>
-            <a:off x="2377440" y="2103120"/>
+            <a:off x="2377440" y="1325880"/>
             <a:ext cx="1371600" cy="457200"/>
           </a:xfrm>
           <a:prstGeom prst="rect">
@@ -2212,7 +2013,7 @@
           <a:bodyPr wrap="square" rtlCol="0" anchor="ctr"/>
           <a:lstStyle/>
           <a:p>
-            <a:pPr algn="ctr" indent="0" marL="0">
+            <a:pPr marL="0" indent="0" algn="ctr">
               <a:buNone/>
             </a:pPr>
             <a:r>
@@ -2235,7 +2036,7 @@
         </p:nvSpPr>
         <p:spPr>
           <a:xfrm>
-            <a:off x="2377440" y="2514600"/>
+            <a:off x="2377440" y="1737360"/>
             <a:ext cx="1371600" cy="548640"/>
           </a:xfrm>
           <a:prstGeom prst="rect">
@@ -2248,7 +2049,7 @@
           <a:bodyPr wrap="square" rtlCol="0" anchor="ctr"/>
           <a:lstStyle/>
           <a:p>
-            <a:pPr algn="ctr" indent="0" marL="0">
+            <a:pPr marL="0" indent="0" algn="ctr">
               <a:buNone/>
             </a:pPr>
             <a:r>
@@ -2265,7 +2066,7 @@
             <a:endParaRPr lang="en-US" sz="1100" dirty="0"/>
           </a:p>
           <a:p>
-            <a:pPr algn="ctr" indent="0" marL="0">
+            <a:pPr marL="0" indent="0" algn="ctr">
               <a:buNone/>
             </a:pPr>
             <a:r>
@@ -2291,7 +2092,7 @@
         </p:nvSpPr>
         <p:spPr>
           <a:xfrm>
-            <a:off x="3749040" y="2331720"/>
+            <a:off x="3749040" y="1554480"/>
             <a:ext cx="274320" cy="457200"/>
           </a:xfrm>
           <a:prstGeom prst="rect">
@@ -2304,7 +2105,7 @@
           <a:bodyPr wrap="square" rtlCol="0" anchor="ctr"/>
           <a:lstStyle/>
           <a:p>
-            <a:pPr algn="ctr" indent="0" marL="0">
+            <a:pPr marL="0" indent="0" algn="ctr">
               <a:buNone/>
             </a:pPr>
             <a:r>
@@ -2330,7 +2131,7 @@
         </p:nvSpPr>
         <p:spPr>
           <a:xfrm>
-            <a:off x="4023360" y="2011680"/>
+            <a:off x="4023360" y="1234440"/>
             <a:ext cx="1371600" cy="1097280"/>
           </a:xfrm>
           <a:prstGeom prst="rect">
@@ -2341,6 +2142,13 @@
           </a:solidFill>
           <a:ln/>
         </p:spPr>
+        <p:txBody>
+          <a:bodyPr/>
+          <a:lstStyle/>
+          <a:p>
+            <a:endParaRPr lang="en-US"/>
+          </a:p>
+        </p:txBody>
       </p:sp>
       <p:sp>
         <p:nvSpPr>
@@ -2350,7 +2158,7 @@
         </p:nvSpPr>
         <p:spPr>
           <a:xfrm>
-            <a:off x="4023360" y="2103120"/>
+            <a:off x="4023360" y="1325880"/>
             <a:ext cx="1371600" cy="457200"/>
           </a:xfrm>
           <a:prstGeom prst="rect">
@@ -2363,7 +2171,7 @@
           <a:bodyPr wrap="square" rtlCol="0" anchor="ctr"/>
           <a:lstStyle/>
           <a:p>
-            <a:pPr algn="ctr" indent="0" marL="0">
+            <a:pPr marL="0" indent="0" algn="ctr">
               <a:buNone/>
             </a:pPr>
             <a:r>
@@ -2386,7 +2194,7 @@
         </p:nvSpPr>
         <p:spPr>
           <a:xfrm>
-            <a:off x="4023360" y="2514600"/>
+            <a:off x="4023360" y="1737360"/>
             <a:ext cx="1371600" cy="548640"/>
           </a:xfrm>
           <a:prstGeom prst="rect">
@@ -2399,7 +2207,7 @@
           <a:bodyPr wrap="square" rtlCol="0" anchor="ctr"/>
           <a:lstStyle/>
           <a:p>
-            <a:pPr algn="ctr" indent="0" marL="0">
+            <a:pPr marL="0" indent="0" algn="ctr">
               <a:buNone/>
             </a:pPr>
             <a:r>
@@ -2416,7 +2224,7 @@
             <a:endParaRPr lang="en-US" sz="1100" dirty="0"/>
           </a:p>
           <a:p>
-            <a:pPr algn="ctr" indent="0" marL="0">
+            <a:pPr marL="0" indent="0" algn="ctr">
               <a:buNone/>
             </a:pPr>
             <a:r>
@@ -2442,7 +2250,7 @@
         </p:nvSpPr>
         <p:spPr>
           <a:xfrm>
-            <a:off x="5394960" y="2331720"/>
+            <a:off x="5394960" y="1554480"/>
             <a:ext cx="274320" cy="457200"/>
           </a:xfrm>
           <a:prstGeom prst="rect">
@@ -2455,7 +2263,7 @@
           <a:bodyPr wrap="square" rtlCol="0" anchor="ctr"/>
           <a:lstStyle/>
           <a:p>
-            <a:pPr algn="ctr" indent="0" marL="0">
+            <a:pPr marL="0" indent="0" algn="ctr">
               <a:buNone/>
             </a:pPr>
             <a:r>
@@ -2481,7 +2289,7 @@
         </p:nvSpPr>
         <p:spPr>
           <a:xfrm>
-            <a:off x="5669280" y="2011680"/>
+            <a:off x="5669280" y="1234440"/>
             <a:ext cx="1371600" cy="1097280"/>
           </a:xfrm>
           <a:prstGeom prst="rect">
@@ -2492,6 +2300,13 @@
           </a:solidFill>
           <a:ln/>
         </p:spPr>
+        <p:txBody>
+          <a:bodyPr/>
+          <a:lstStyle/>
+          <a:p>
+            <a:endParaRPr lang="en-US"/>
+          </a:p>
+        </p:txBody>
       </p:sp>
       <p:sp>
         <p:nvSpPr>
@@ -2501,7 +2316,7 @@
         </p:nvSpPr>
         <p:spPr>
           <a:xfrm>
-            <a:off x="5669280" y="2103120"/>
+            <a:off x="5669280" y="1325880"/>
             <a:ext cx="1371600" cy="457200"/>
           </a:xfrm>
           <a:prstGeom prst="rect">
@@ -2514,7 +2329,7 @@
           <a:bodyPr wrap="square" rtlCol="0" anchor="ctr"/>
           <a:lstStyle/>
           <a:p>
-            <a:pPr algn="ctr" indent="0" marL="0">
+            <a:pPr marL="0" indent="0" algn="ctr">
               <a:buNone/>
             </a:pPr>
             <a:r>
@@ -2537,7 +2352,7 @@
         </p:nvSpPr>
         <p:spPr>
           <a:xfrm>
-            <a:off x="5669280" y="2514600"/>
+            <a:off x="5669280" y="1737360"/>
             <a:ext cx="1371600" cy="548640"/>
           </a:xfrm>
           <a:prstGeom prst="rect">
@@ -2550,7 +2365,7 @@
           <a:bodyPr wrap="square" rtlCol="0" anchor="ctr"/>
           <a:lstStyle/>
           <a:p>
-            <a:pPr algn="ctr" indent="0" marL="0">
+            <a:pPr marL="0" indent="0" algn="ctr">
               <a:buNone/>
             </a:pPr>
             <a:r>
@@ -2567,7 +2382,7 @@
             <a:endParaRPr lang="en-US" sz="1100" dirty="0"/>
           </a:p>
           <a:p>
-            <a:pPr algn="ctr" indent="0" marL="0">
+            <a:pPr marL="0" indent="0" algn="ctr">
               <a:buNone/>
             </a:pPr>
             <a:r>
@@ -2593,7 +2408,7 @@
         </p:nvSpPr>
         <p:spPr>
           <a:xfrm>
-            <a:off x="7040880" y="2331720"/>
+            <a:off x="7040880" y="1554480"/>
             <a:ext cx="274320" cy="457200"/>
           </a:xfrm>
           <a:prstGeom prst="rect">
@@ -2606,7 +2421,7 @@
           <a:bodyPr wrap="square" rtlCol="0" anchor="ctr"/>
           <a:lstStyle/>
           <a:p>
-            <a:pPr algn="ctr" indent="0" marL="0">
+            <a:pPr marL="0" indent="0" algn="ctr">
               <a:buNone/>
             </a:pPr>
             <a:r>
@@ -2632,7 +2447,7 @@
         </p:nvSpPr>
         <p:spPr>
           <a:xfrm>
-            <a:off x="7315200" y="2011680"/>
+            <a:off x="7315200" y="1234440"/>
             <a:ext cx="1371600" cy="1097280"/>
           </a:xfrm>
           <a:prstGeom prst="rect">
@@ -2643,6 +2458,13 @@
           </a:solidFill>
           <a:ln/>
         </p:spPr>
+        <p:txBody>
+          <a:bodyPr/>
+          <a:lstStyle/>
+          <a:p>
+            <a:endParaRPr lang="en-US"/>
+          </a:p>
+        </p:txBody>
       </p:sp>
       <p:sp>
         <p:nvSpPr>
@@ -2652,7 +2474,7 @@
         </p:nvSpPr>
         <p:spPr>
           <a:xfrm>
-            <a:off x="7315200" y="2103120"/>
+            <a:off x="7315200" y="1325880"/>
             <a:ext cx="1371600" cy="457200"/>
           </a:xfrm>
           <a:prstGeom prst="rect">
@@ -2665,7 +2487,7 @@
           <a:bodyPr wrap="square" rtlCol="0" anchor="ctr"/>
           <a:lstStyle/>
           <a:p>
-            <a:pPr algn="ctr" indent="0" marL="0">
+            <a:pPr marL="0" indent="0" algn="ctr">
               <a:buNone/>
             </a:pPr>
             <a:r>
@@ -2688,7 +2510,7 @@
         </p:nvSpPr>
         <p:spPr>
           <a:xfrm>
-            <a:off x="7315200" y="2514600"/>
+            <a:off x="7315200" y="1737360"/>
             <a:ext cx="1371600" cy="548640"/>
           </a:xfrm>
           <a:prstGeom prst="rect">
@@ -2701,7 +2523,7 @@
           <a:bodyPr wrap="square" rtlCol="0" anchor="ctr"/>
           <a:lstStyle/>
           <a:p>
-            <a:pPr algn="ctr" indent="0" marL="0">
+            <a:pPr marL="0" indent="0" algn="ctr">
               <a:buNone/>
             </a:pPr>
             <a:r>
@@ -2718,7 +2540,7 @@
             <a:endParaRPr lang="en-US" sz="1100" dirty="0"/>
           </a:p>
           <a:p>
-            <a:pPr algn="ctr" indent="0" marL="0">
+            <a:pPr marL="0" indent="0" algn="ctr">
               <a:buNone/>
             </a:pPr>
             <a:r>
@@ -2744,7 +2566,7 @@
         </p:nvSpPr>
         <p:spPr>
           <a:xfrm>
-            <a:off x="457200" y="3383280"/>
+            <a:off x="457200" y="2606040"/>
             <a:ext cx="2743200" cy="365760"/>
           </a:xfrm>
           <a:prstGeom prst="rect">
@@ -2757,7 +2579,7 @@
           <a:bodyPr wrap="square" rtlCol="0" anchor="ctr"/>
           <a:lstStyle/>
           <a:p>
-            <a:pPr indent="0" marL="0">
+            <a:pPr marL="0" indent="0">
               <a:buNone/>
             </a:pPr>
             <a:r>
@@ -2777,30 +2599,48 @@
       </p:sp>
       <p:graphicFrame>
         <p:nvGraphicFramePr>
-          <p:cNvPr id="4" name="Table 0"/>
+          <p:cNvPr id="23" name="Table 0"/>
           <p:cNvGraphicFramePr>
             <a:graphicFrameLocks noGrp="1"/>
           </p:cNvGraphicFramePr>
           <p:nvPr>
             <p:extLst>
               <p:ext uri="{D42A27DB-BD31-4B8C-83A1-F6EECF244321}">
-                <p14:modId xmlns:p14="http://schemas.microsoft.com/office/powerpoint/2010/main" val="1579011935"/>
+                <p14:modId xmlns:p14="http://schemas.microsoft.com/office/powerpoint/2010/main" val="3539463450"/>
               </p:ext>
             </p:extLst>
           </p:nvPr>
         </p:nvGraphicFramePr>
         <p:xfrm>
-          <a:off x="457200" y="3749040"/>
-          <a:ext cx="8229600" cy="1280160"/>
+          <a:off x="457200" y="3056709"/>
+          <a:ext cx="8229600" cy="1813560"/>
         </p:xfrm>
         <a:graphic>
           <a:graphicData uri="http://schemas.openxmlformats.org/drawingml/2006/table">
             <a:tbl>
               <a:tblPr/>
               <a:tblGrid>
-                <a:gridCol w="2743200"/>
-                <a:gridCol w="2743200"/>
-                <a:gridCol w="2743200"/>
+                <a:gridCol w="2743200">
+                  <a:extLst>
+                    <a:ext uri="{9D8B030D-6E8A-4147-A177-3AD203B41FA5}">
+                      <a16:colId xmlns:a16="http://schemas.microsoft.com/office/drawing/2014/main" val="20000"/>
+                    </a:ext>
+                  </a:extLst>
+                </a:gridCol>
+                <a:gridCol w="2743200">
+                  <a:extLst>
+                    <a:ext uri="{9D8B030D-6E8A-4147-A177-3AD203B41FA5}">
+                      <a16:colId xmlns:a16="http://schemas.microsoft.com/office/drawing/2014/main" val="20001"/>
+                    </a:ext>
+                  </a:extLst>
+                </a:gridCol>
+                <a:gridCol w="2743200">
+                  <a:extLst>
+                    <a:ext uri="{9D8B030D-6E8A-4147-A177-3AD203B41FA5}">
+                      <a16:colId xmlns:a16="http://schemas.microsoft.com/office/drawing/2014/main" val="20002"/>
+                    </a:ext>
+                  </a:extLst>
+                </a:gridCol>
               </a:tblGrid>
               <a:tr h="182880">
                 <a:tc>
@@ -2808,7 +2648,7 @@
                     <a:bodyPr/>
                     <a:lstStyle/>
                     <a:p>
-                      <a:pPr indent="0" marL="0">
+                      <a:pPr marL="0" indent="0">
                         <a:buNone/>
                       </a:pPr>
                       <a:r>
@@ -2829,7 +2669,7 @@
                       </a:endParaRPr>
                     </a:p>
                   </a:txBody>
-                  <a:tcPr marL="91440" marR="91440" marT="45720" marB="45720">
+                  <a:tcPr>
                     <a:lnL w="6350" cap="flat" cmpd="sng" algn="ctr">
                       <a:solidFill>
                         <a:srgbClr val="94A3B8"/>
@@ -2876,7 +2716,7 @@
                     <a:bodyPr/>
                     <a:lstStyle/>
                     <a:p>
-                      <a:pPr indent="0" marL="0">
+                      <a:pPr marL="0" indent="0">
                         <a:buNone/>
                       </a:pPr>
                       <a:r>
@@ -2897,7 +2737,7 @@
                       </a:endParaRPr>
                     </a:p>
                   </a:txBody>
-                  <a:tcPr marL="91440" marR="91440" marT="45720" marB="45720">
+                  <a:tcPr>
                     <a:lnL w="6350" cap="flat" cmpd="sng" algn="ctr">
                       <a:solidFill>
                         <a:srgbClr val="94A3B8"/>
@@ -2944,7 +2784,7 @@
                     <a:bodyPr/>
                     <a:lstStyle/>
                     <a:p>
-                      <a:pPr indent="0" marL="0">
+                      <a:pPr marL="0" indent="0">
                         <a:buNone/>
                       </a:pPr>
                       <a:r>
@@ -2965,7 +2805,7 @@
                       </a:endParaRPr>
                     </a:p>
                   </a:txBody>
-                  <a:tcPr marL="91440" marR="91440" marT="45720" marB="45720">
+                  <a:tcPr>
                     <a:lnL w="6350" cap="flat" cmpd="sng" algn="ctr">
                       <a:solidFill>
                         <a:srgbClr val="94A3B8"/>
@@ -3007,6 +2847,11 @@
                     </a:solidFill>
                   </a:tcPr>
                 </a:tc>
+                <a:extLst>
+                  <a:ext uri="{0D108BD9-81ED-4DB2-BD59-A6C34878D82A}">
+                    <a16:rowId xmlns:a16="http://schemas.microsoft.com/office/drawing/2014/main" val="10000"/>
+                  </a:ext>
+                </a:extLst>
               </a:tr>
               <a:tr h="182880">
                 <a:tc>
@@ -3014,7 +2859,7 @@
                     <a:bodyPr/>
                     <a:lstStyle/>
                     <a:p>
-                      <a:pPr indent="0" marL="0">
+                      <a:pPr marL="0" indent="0">
                         <a:buNone/>
                       </a:pPr>
                       <a:r>
@@ -3035,7 +2880,7 @@
                       </a:endParaRPr>
                     </a:p>
                   </a:txBody>
-                  <a:tcPr marL="91440" marR="91440" marT="45720" marB="45720">
+                  <a:tcPr>
                     <a:lnL w="6350" cap="flat" cmpd="sng" algn="ctr">
                       <a:solidFill>
                         <a:srgbClr val="94A3B8"/>
@@ -3082,7 +2927,7 @@
                     <a:bodyPr/>
                     <a:lstStyle/>
                     <a:p>
-                      <a:pPr indent="0" marL="0">
+                      <a:pPr marL="0" indent="0">
                         <a:buNone/>
                       </a:pPr>
                       <a:r>
@@ -3103,7 +2948,7 @@
                       </a:endParaRPr>
                     </a:p>
                   </a:txBody>
-                  <a:tcPr marL="91440" marR="91440" marT="45720" marB="45720">
+                  <a:tcPr>
                     <a:lnL w="6350" cap="flat" cmpd="sng" algn="ctr">
                       <a:solidFill>
                         <a:srgbClr val="94A3B8"/>
@@ -3150,7 +2995,7 @@
                     <a:bodyPr/>
                     <a:lstStyle/>
                     <a:p>
-                      <a:pPr indent="0" marL="0">
+                      <a:pPr marL="0" indent="0">
                         <a:buNone/>
                       </a:pPr>
                       <a:r>
@@ -3171,7 +3016,7 @@
                       </a:endParaRPr>
                     </a:p>
                   </a:txBody>
-                  <a:tcPr marL="91440" marR="91440" marT="45720" marB="45720">
+                  <a:tcPr>
                     <a:lnL w="6350" cap="flat" cmpd="sng" algn="ctr">
                       <a:solidFill>
                         <a:srgbClr val="94A3B8"/>
@@ -3213,6 +3058,11 @@
                     </a:solidFill>
                   </a:tcPr>
                 </a:tc>
+                <a:extLst>
+                  <a:ext uri="{0D108BD9-81ED-4DB2-BD59-A6C34878D82A}">
+                    <a16:rowId xmlns:a16="http://schemas.microsoft.com/office/drawing/2014/main" val="10001"/>
+                  </a:ext>
+                </a:extLst>
               </a:tr>
               <a:tr h="182880">
                 <a:tc>
@@ -3220,7 +3070,7 @@
                     <a:bodyPr/>
                     <a:lstStyle/>
                     <a:p>
-                      <a:pPr indent="0" marL="0">
+                      <a:pPr marL="0" indent="0">
                         <a:buNone/>
                       </a:pPr>
                       <a:r>
@@ -3241,7 +3091,7 @@
                       </a:endParaRPr>
                     </a:p>
                   </a:txBody>
-                  <a:tcPr marL="91440" marR="91440" marT="45720" marB="45720">
+                  <a:tcPr>
                     <a:lnL w="6350" cap="flat" cmpd="sng" algn="ctr">
                       <a:solidFill>
                         <a:srgbClr val="94A3B8"/>
@@ -3288,7 +3138,7 @@
                     <a:bodyPr/>
                     <a:lstStyle/>
                     <a:p>
-                      <a:pPr indent="0" marL="0">
+                      <a:pPr marL="0" indent="0">
                         <a:buNone/>
                       </a:pPr>
                       <a:r>
@@ -3300,7 +3150,7 @@
                           <a:ea typeface="Arial" pitchFamily="34" charset="-122"/>
                           <a:cs typeface="Arial" pitchFamily="34" charset="-120"/>
                         </a:rPr>
-                        <a:t>GPT-4o-mini</a:t>
+                        <a:t>Groq (llama-3.3-70b)</a:t>
                       </a:r>
                       <a:endParaRPr lang="en-US" sz="1100" dirty="0">
                         <a:latin typeface="Arial" charset="0"/>
@@ -3309,7 +3159,7 @@
                       </a:endParaRPr>
                     </a:p>
                   </a:txBody>
-                  <a:tcPr marL="91440" marR="91440" marT="45720" marB="45720">
+                  <a:tcPr>
                     <a:lnL w="6350" cap="flat" cmpd="sng" algn="ctr">
                       <a:solidFill>
                         <a:srgbClr val="94A3B8"/>
@@ -3356,7 +3206,7 @@
                     <a:bodyPr/>
                     <a:lstStyle/>
                     <a:p>
-                      <a:pPr indent="0" marL="0">
+                      <a:pPr marL="0" indent="0">
                         <a:buNone/>
                       </a:pPr>
                       <a:r>
@@ -3368,7 +3218,7 @@
                           <a:ea typeface="Arial" pitchFamily="34" charset="-122"/>
                           <a:cs typeface="Arial" pitchFamily="34" charset="-120"/>
                         </a:rPr>
-                        <a:t>$0.20</a:t>
+                        <a:t>$0.00 (free)</a:t>
                       </a:r>
                       <a:endParaRPr lang="en-US" sz="1100" dirty="0">
                         <a:latin typeface="Arial" charset="0"/>
@@ -3377,7 +3227,7 @@
                       </a:endParaRPr>
                     </a:p>
                   </a:txBody>
-                  <a:tcPr marL="91440" marR="91440" marT="45720" marB="45720">
+                  <a:tcPr>
                     <a:lnL w="6350" cap="flat" cmpd="sng" algn="ctr">
                       <a:solidFill>
                         <a:srgbClr val="94A3B8"/>
@@ -3419,6 +3269,11 @@
                     </a:solidFill>
                   </a:tcPr>
                 </a:tc>
+                <a:extLst>
+                  <a:ext uri="{0D108BD9-81ED-4DB2-BD59-A6C34878D82A}">
+                    <a16:rowId xmlns:a16="http://schemas.microsoft.com/office/drawing/2014/main" val="10002"/>
+                  </a:ext>
+                </a:extLst>
               </a:tr>
               <a:tr h="182880">
                 <a:tc>
@@ -3426,7 +3281,7 @@
                     <a:bodyPr/>
                     <a:lstStyle/>
                     <a:p>
-                      <a:pPr indent="0" marL="0">
+                      <a:pPr marL="0" indent="0">
                         <a:buNone/>
                       </a:pPr>
                       <a:r>
@@ -3447,7 +3302,7 @@
                       </a:endParaRPr>
                     </a:p>
                   </a:txBody>
-                  <a:tcPr marL="91440" marR="91440" marT="45720" marB="45720">
+                  <a:tcPr>
                     <a:lnL w="6350" cap="flat" cmpd="sng" algn="ctr">
                       <a:solidFill>
                         <a:srgbClr val="94A3B8"/>
@@ -3494,7 +3349,7 @@
                     <a:bodyPr/>
                     <a:lstStyle/>
                     <a:p>
-                      <a:pPr indent="0" marL="0">
+                      <a:pPr marL="0" indent="0">
                         <a:buNone/>
                       </a:pPr>
                       <a:r>
@@ -3515,7 +3370,7 @@
                       </a:endParaRPr>
                     </a:p>
                   </a:txBody>
-                  <a:tcPr marL="91440" marR="91440" marT="45720" marB="45720">
+                  <a:tcPr>
                     <a:lnL w="6350" cap="flat" cmpd="sng" algn="ctr">
                       <a:solidFill>
                         <a:srgbClr val="94A3B8"/>
@@ -3562,7 +3417,7 @@
                     <a:bodyPr/>
                     <a:lstStyle/>
                     <a:p>
-                      <a:pPr indent="0" marL="0">
+                      <a:pPr marL="0" indent="0">
                         <a:buNone/>
                       </a:pPr>
                       <a:r>
@@ -3583,7 +3438,7 @@
                       </a:endParaRPr>
                     </a:p>
                   </a:txBody>
-                  <a:tcPr marL="91440" marR="91440" marT="45720" marB="45720">
+                  <a:tcPr>
                     <a:lnL w="6350" cap="flat" cmpd="sng" algn="ctr">
                       <a:solidFill>
                         <a:srgbClr val="94A3B8"/>
@@ -3625,6 +3480,11 @@
                     </a:solidFill>
                   </a:tcPr>
                 </a:tc>
+                <a:extLst>
+                  <a:ext uri="{0D108BD9-81ED-4DB2-BD59-A6C34878D82A}">
+                    <a16:rowId xmlns:a16="http://schemas.microsoft.com/office/drawing/2014/main" val="10003"/>
+                  </a:ext>
+                </a:extLst>
               </a:tr>
               <a:tr h="182880">
                 <a:tc>
@@ -3632,7 +3492,7 @@
                     <a:bodyPr/>
                     <a:lstStyle/>
                     <a:p>
-                      <a:pPr indent="0" marL="0">
+                      <a:pPr marL="0" indent="0">
                         <a:buNone/>
                       </a:pPr>
                       <a:r>
@@ -3653,7 +3513,7 @@
                       </a:endParaRPr>
                     </a:p>
                   </a:txBody>
-                  <a:tcPr marL="91440" marR="91440" marT="45720" marB="45720">
+                  <a:tcPr>
                     <a:lnL w="6350" cap="flat" cmpd="sng" algn="ctr">
                       <a:solidFill>
                         <a:srgbClr val="94A3B8"/>
@@ -3700,7 +3560,7 @@
                     <a:bodyPr/>
                     <a:lstStyle/>
                     <a:p>
-                      <a:pPr indent="0" marL="0">
+                      <a:pPr marL="0" indent="0">
                         <a:buNone/>
                       </a:pPr>
                       <a:r>
@@ -3721,7 +3581,7 @@
                       </a:endParaRPr>
                     </a:p>
                   </a:txBody>
-                  <a:tcPr marL="91440" marR="91440" marT="45720" marB="45720">
+                  <a:tcPr>
                     <a:lnL w="6350" cap="flat" cmpd="sng" algn="ctr">
                       <a:solidFill>
                         <a:srgbClr val="94A3B8"/>
@@ -3768,7 +3628,7 @@
                     <a:bodyPr/>
                     <a:lstStyle/>
                     <a:p>
-                      <a:pPr indent="0" marL="0">
+                      <a:pPr marL="0" indent="0">
                         <a:buNone/>
                       </a:pPr>
                       <a:r>
@@ -3789,7 +3649,7 @@
                       </a:endParaRPr>
                     </a:p>
                   </a:txBody>
-                  <a:tcPr marL="91440" marR="91440" marT="45720" marB="45720">
+                  <a:tcPr>
                     <a:lnL w="6350" cap="flat" cmpd="sng" algn="ctr">
                       <a:solidFill>
                         <a:srgbClr val="94A3B8"/>
@@ -3831,6 +3691,11 @@
                     </a:solidFill>
                   </a:tcPr>
                 </a:tc>
+                <a:extLst>
+                  <a:ext uri="{0D108BD9-81ED-4DB2-BD59-A6C34878D82A}">
+                    <a16:rowId xmlns:a16="http://schemas.microsoft.com/office/drawing/2014/main" val="10004"/>
+                  </a:ext>
+                </a:extLst>
               </a:tr>
               <a:tr h="182880">
                 <a:tc>
@@ -3838,7 +3703,7 @@
                     <a:bodyPr/>
                     <a:lstStyle/>
                     <a:p>
-                      <a:pPr indent="0" marL="0">
+                      <a:pPr marL="0" indent="0">
                         <a:buNone/>
                       </a:pPr>
                       <a:r>
@@ -3859,7 +3724,7 @@
                       </a:endParaRPr>
                     </a:p>
                   </a:txBody>
-                  <a:tcPr marL="91440" marR="91440" marT="45720" marB="45720">
+                  <a:tcPr>
                     <a:lnL w="6350" cap="flat" cmpd="sng" algn="ctr">
                       <a:solidFill>
                         <a:srgbClr val="94A3B8"/>
@@ -3906,7 +3771,7 @@
                     <a:bodyPr/>
                     <a:lstStyle/>
                     <a:p>
-                      <a:pPr indent="0" marL="0">
+                      <a:pPr marL="0" indent="0">
                         <a:buNone/>
                       </a:pPr>
                       <a:r>
@@ -3927,7 +3792,7 @@
                       </a:endParaRPr>
                     </a:p>
                   </a:txBody>
-                  <a:tcPr marL="91440" marR="91440" marT="45720" marB="45720">
+                  <a:tcPr>
                     <a:lnL w="6350" cap="flat" cmpd="sng" algn="ctr">
                       <a:solidFill>
                         <a:srgbClr val="94A3B8"/>
@@ -3974,7 +3839,7 @@
                     <a:bodyPr/>
                     <a:lstStyle/>
                     <a:p>
-                      <a:pPr indent="0" marL="0">
+                      <a:pPr marL="0" indent="0">
                         <a:buNone/>
                       </a:pPr>
                       <a:r>
@@ -3995,7 +3860,7 @@
                       </a:endParaRPr>
                     </a:p>
                   </a:txBody>
-                  <a:tcPr marL="91440" marR="91440" marT="45720" marB="45720">
+                  <a:tcPr>
                     <a:lnL w="6350" cap="flat" cmpd="sng" algn="ctr">
                       <a:solidFill>
                         <a:srgbClr val="94A3B8"/>
@@ -4037,6 +3902,11 @@
                     </a:solidFill>
                   </a:tcPr>
                 </a:tc>
+                <a:extLst>
+                  <a:ext uri="{0D108BD9-81ED-4DB2-BD59-A6C34878D82A}">
+                    <a16:rowId xmlns:a16="http://schemas.microsoft.com/office/drawing/2014/main" val="10005"/>
+                  </a:ext>
+                </a:extLst>
               </a:tr>
               <a:tr h="182880">
                 <a:tc>
@@ -4044,7 +3914,7 @@
                     <a:bodyPr/>
                     <a:lstStyle/>
                     <a:p>
-                      <a:pPr indent="0" marL="0">
+                      <a:pPr marL="0" indent="0">
                         <a:buNone/>
                       </a:pPr>
                       <a:r>
@@ -4065,7 +3935,7 @@
                       </a:endParaRPr>
                     </a:p>
                   </a:txBody>
-                  <a:tcPr marL="91440" marR="91440" marT="45720" marB="45720">
+                  <a:tcPr>
                     <a:lnL w="6350" cap="flat" cmpd="sng" algn="ctr">
                       <a:solidFill>
                         <a:srgbClr val="94A3B8"/>
@@ -4112,7 +3982,7 @@
                     <a:bodyPr/>
                     <a:lstStyle/>
                     <a:p>
-                      <a:pPr indent="0" marL="0">
+                      <a:pPr marL="0" indent="0">
                         <a:buNone/>
                       </a:pPr>
                       <a:r>
@@ -4133,7 +4003,7 @@
                       </a:endParaRPr>
                     </a:p>
                   </a:txBody>
-                  <a:tcPr marL="91440" marR="91440" marT="45720" marB="45720">
+                  <a:tcPr>
                     <a:lnL w="6350" cap="flat" cmpd="sng" algn="ctr">
                       <a:solidFill>
                         <a:srgbClr val="94A3B8"/>
@@ -4180,7 +4050,7 @@
                     <a:bodyPr/>
                     <a:lstStyle/>
                     <a:p>
-                      <a:pPr indent="0" marL="0">
+                      <a:pPr marL="0" indent="0">
                         <a:buNone/>
                       </a:pPr>
                       <a:r>
@@ -4201,7 +4071,7 @@
                       </a:endParaRPr>
                     </a:p>
                   </a:txBody>
-                  <a:tcPr marL="91440" marR="91440" marT="45720" marB="45720">
+                  <a:tcPr>
                     <a:lnL w="6350" cap="flat" cmpd="sng" algn="ctr">
                       <a:solidFill>
                         <a:srgbClr val="94A3B8"/>
@@ -4243,6 +4113,11 @@
                     </a:solidFill>
                   </a:tcPr>
                 </a:tc>
+                <a:extLst>
+                  <a:ext uri="{0D108BD9-81ED-4DB2-BD59-A6C34878D82A}">
+                    <a16:rowId xmlns:a16="http://schemas.microsoft.com/office/drawing/2014/main" val="10006"/>
+                  </a:ext>
+                </a:extLst>
               </a:tr>
             </a:tbl>
           </a:graphicData>
@@ -4264,6 +4139,7 @@
         <a:solidFill>
           <a:srgbClr val="1E293B"/>
         </a:solidFill>
+        <a:effectLst/>
       </p:bgPr>
     </p:bg>
     <p:spTree>
@@ -4301,7 +4177,7 @@
           <a:bodyPr wrap="square" rtlCol="0" anchor="ctr"/>
           <a:lstStyle/>
           <a:p>
-            <a:pPr indent="0" marL="0">
+            <a:pPr marL="0" indent="0">
               <a:buNone/>
             </a:pPr>
             <a:r>
@@ -4327,7 +4203,7 @@
         </p:nvSpPr>
         <p:spPr>
           <a:xfrm>
-            <a:off x="457200" y="914400"/>
+            <a:off x="493776" y="1012371"/>
             <a:ext cx="3931920" cy="1828800"/>
           </a:xfrm>
           <a:prstGeom prst="rect">
@@ -4338,6 +4214,13 @@
           </a:solidFill>
           <a:ln/>
         </p:spPr>
+        <p:txBody>
+          <a:bodyPr/>
+          <a:lstStyle/>
+          <a:p>
+            <a:endParaRPr lang="en-US"/>
+          </a:p>
+        </p:txBody>
       </p:sp>
       <p:sp>
         <p:nvSpPr>
@@ -4347,7 +4230,7 @@
         </p:nvSpPr>
         <p:spPr>
           <a:xfrm>
-            <a:off x="457200" y="914400"/>
+            <a:off x="457200" y="999308"/>
             <a:ext cx="73152" cy="1828800"/>
           </a:xfrm>
           <a:prstGeom prst="rect">
@@ -4358,6 +4241,13 @@
           </a:solidFill>
           <a:ln/>
         </p:spPr>
+        <p:txBody>
+          <a:bodyPr/>
+          <a:lstStyle/>
+          <a:p>
+            <a:endParaRPr lang="en-US"/>
+          </a:p>
+        </p:txBody>
       </p:sp>
       <p:sp>
         <p:nvSpPr>
@@ -4380,7 +4270,7 @@
           <a:bodyPr wrap="square" rtlCol="0" anchor="ctr"/>
           <a:lstStyle/>
           <a:p>
-            <a:pPr indent="0" marL="0">
+            <a:pPr marL="0" indent="0">
               <a:buNone/>
             </a:pPr>
             <a:r>
@@ -4419,7 +4309,7 @@
           <a:bodyPr wrap="square" rtlCol="0" anchor="t"/>
           <a:lstStyle/>
           <a:p>
-            <a:pPr indent="0" marL="0">
+            <a:pPr marL="0" indent="0">
               <a:buNone/>
             </a:pPr>
             <a:r>
@@ -4458,7 +4348,7 @@
           <a:bodyPr wrap="square" rtlCol="0" anchor="ctr"/>
           <a:lstStyle/>
           <a:p>
-            <a:pPr indent="0" marL="0">
+            <a:pPr marL="0" indent="0">
               <a:buNone/>
             </a:pPr>
             <a:r>
@@ -4484,7 +4374,7 @@
         </p:nvSpPr>
         <p:spPr>
           <a:xfrm>
-            <a:off x="4754880" y="914400"/>
+            <a:off x="4754880" y="999308"/>
             <a:ext cx="3931920" cy="1828800"/>
           </a:xfrm>
           <a:prstGeom prst="rect">
@@ -4495,6 +4385,13 @@
           </a:solidFill>
           <a:ln/>
         </p:spPr>
+        <p:txBody>
+          <a:bodyPr/>
+          <a:lstStyle/>
+          <a:p>
+            <a:endParaRPr lang="en-US"/>
+          </a:p>
+        </p:txBody>
       </p:sp>
       <p:sp>
         <p:nvSpPr>
@@ -4504,7 +4401,7 @@
         </p:nvSpPr>
         <p:spPr>
           <a:xfrm>
-            <a:off x="4754880" y="914400"/>
+            <a:off x="4754880" y="999308"/>
             <a:ext cx="73152" cy="1828800"/>
           </a:xfrm>
           <a:prstGeom prst="rect">
@@ -4515,6 +4412,13 @@
           </a:solidFill>
           <a:ln/>
         </p:spPr>
+        <p:txBody>
+          <a:bodyPr/>
+          <a:lstStyle/>
+          <a:p>
+            <a:endParaRPr lang="en-US"/>
+          </a:p>
+        </p:txBody>
       </p:sp>
       <p:sp>
         <p:nvSpPr>
@@ -4537,7 +4441,7 @@
           <a:bodyPr wrap="square" rtlCol="0" anchor="ctr"/>
           <a:lstStyle/>
           <a:p>
-            <a:pPr indent="0" marL="0">
+            <a:pPr marL="0" indent="0">
               <a:buNone/>
             </a:pPr>
             <a:r>
@@ -4576,7 +4480,7 @@
           <a:bodyPr wrap="square" rtlCol="0" anchor="t"/>
           <a:lstStyle/>
           <a:p>
-            <a:pPr indent="0" marL="0">
+            <a:pPr marL="0" indent="0">
               <a:buNone/>
             </a:pPr>
             <a:r>
@@ -4615,7 +4519,7 @@
           <a:bodyPr wrap="square" rtlCol="0" anchor="ctr"/>
           <a:lstStyle/>
           <a:p>
-            <a:pPr indent="0" marL="0">
+            <a:pPr marL="0" indent="0">
               <a:buNone/>
             </a:pPr>
             <a:r>
@@ -4652,6 +4556,13 @@
           </a:solidFill>
           <a:ln/>
         </p:spPr>
+        <p:txBody>
+          <a:bodyPr/>
+          <a:lstStyle/>
+          <a:p>
+            <a:endParaRPr lang="en-US"/>
+          </a:p>
+        </p:txBody>
       </p:sp>
       <p:sp>
         <p:nvSpPr>
@@ -4672,6 +4583,13 @@
           </a:solidFill>
           <a:ln/>
         </p:spPr>
+        <p:txBody>
+          <a:bodyPr/>
+          <a:lstStyle/>
+          <a:p>
+            <a:endParaRPr lang="en-US"/>
+          </a:p>
+        </p:txBody>
       </p:sp>
       <p:sp>
         <p:nvSpPr>
@@ -4694,7 +4612,7 @@
           <a:bodyPr wrap="square" rtlCol="0" anchor="ctr"/>
           <a:lstStyle/>
           <a:p>
-            <a:pPr indent="0" marL="0">
+            <a:pPr marL="0" indent="0">
               <a:buNone/>
             </a:pPr>
             <a:r>
@@ -4733,7 +4651,7 @@
           <a:bodyPr wrap="square" rtlCol="0" anchor="t"/>
           <a:lstStyle/>
           <a:p>
-            <a:pPr indent="0" marL="0">
+            <a:pPr marL="0" indent="0">
               <a:buNone/>
             </a:pPr>
             <a:r>
@@ -4772,7 +4690,7 @@
           <a:bodyPr wrap="square" rtlCol="0" anchor="ctr"/>
           <a:lstStyle/>
           <a:p>
-            <a:pPr indent="0" marL="0">
+            <a:pPr marL="0" indent="0">
               <a:buNone/>
             </a:pPr>
             <a:r>
@@ -4809,6 +4727,13 @@
           </a:solidFill>
           <a:ln/>
         </p:spPr>
+        <p:txBody>
+          <a:bodyPr/>
+          <a:lstStyle/>
+          <a:p>
+            <a:endParaRPr lang="en-US"/>
+          </a:p>
+        </p:txBody>
       </p:sp>
       <p:sp>
         <p:nvSpPr>
@@ -4829,6 +4754,13 @@
           </a:solidFill>
           <a:ln/>
         </p:spPr>
+        <p:txBody>
+          <a:bodyPr/>
+          <a:lstStyle/>
+          <a:p>
+            <a:endParaRPr lang="en-US"/>
+          </a:p>
+        </p:txBody>
       </p:sp>
       <p:sp>
         <p:nvSpPr>
@@ -4851,7 +4783,7 @@
           <a:bodyPr wrap="square" rtlCol="0" anchor="ctr"/>
           <a:lstStyle/>
           <a:p>
-            <a:pPr indent="0" marL="0">
+            <a:pPr marL="0" indent="0">
               <a:buNone/>
             </a:pPr>
             <a:r>
@@ -4890,7 +4822,7 @@
           <a:bodyPr wrap="square" rtlCol="0" anchor="t"/>
           <a:lstStyle/>
           <a:p>
-            <a:pPr indent="0" marL="0">
+            <a:pPr marL="0" indent="0">
               <a:buNone/>
             </a:pPr>
             <a:r>
@@ -4929,7 +4861,7 @@
           <a:bodyPr wrap="square" rtlCol="0" anchor="ctr"/>
           <a:lstStyle/>
           <a:p>
-            <a:pPr indent="0" marL="0">
+            <a:pPr marL="0" indent="0">
               <a:buNone/>
             </a:pPr>
             <a:r>
@@ -4963,6 +4895,7 @@
         <a:solidFill>
           <a:srgbClr val="1E293B"/>
         </a:solidFill>
+        <a:effectLst/>
       </p:bgPr>
     </p:bg>
     <p:spTree>
@@ -5000,7 +4933,7 @@
           <a:bodyPr wrap="square" rtlCol="0" anchor="ctr"/>
           <a:lstStyle/>
           <a:p>
-            <a:pPr indent="0" marL="0">
+            <a:pPr marL="0" indent="0">
               <a:buNone/>
             </a:pPr>
             <a:r>
@@ -5026,8 +4959,8 @@
         </p:nvSpPr>
         <p:spPr>
           <a:xfrm>
-            <a:off x="457200" y="914400"/>
-            <a:ext cx="3931920" cy="2560320"/>
+            <a:off x="457200" y="1014549"/>
+            <a:ext cx="3931920" cy="1907177"/>
           </a:xfrm>
           <a:prstGeom prst="rect">
             <a:avLst/>
@@ -5037,6 +4970,13 @@
           </a:solidFill>
           <a:ln/>
         </p:spPr>
+        <p:txBody>
+          <a:bodyPr/>
+          <a:lstStyle/>
+          <a:p>
+            <a:endParaRPr lang="en-US"/>
+          </a:p>
+        </p:txBody>
       </p:sp>
       <p:sp>
         <p:nvSpPr>
@@ -5046,7 +4986,7 @@
         </p:nvSpPr>
         <p:spPr>
           <a:xfrm>
-            <a:off x="640080" y="1005840"/>
+            <a:off x="640080" y="1180012"/>
             <a:ext cx="3657600" cy="365760"/>
           </a:xfrm>
           <a:prstGeom prst="rect">
@@ -5059,7 +4999,7 @@
           <a:bodyPr wrap="square" rtlCol="0" anchor="ctr"/>
           <a:lstStyle/>
           <a:p>
-            <a:pPr indent="0" marL="0">
+            <a:pPr marL="0" indent="0">
               <a:buNone/>
             </a:pPr>
             <a:r>
@@ -5085,7 +5025,7 @@
         </p:nvSpPr>
         <p:spPr>
           <a:xfrm>
-            <a:off x="640080" y="1463040"/>
+            <a:off x="640080" y="1657350"/>
             <a:ext cx="3657600" cy="1828800"/>
           </a:xfrm>
           <a:prstGeom prst="rect">
@@ -5165,24 +5105,6 @@
                 <a:ea typeface="Arial" pitchFamily="34" charset="-122"/>
                 <a:cs typeface="Arial" pitchFamily="34" charset="-120"/>
               </a:rPr>
-              <a:t>No speaker identification in MVP</a:t>
-            </a:r>
-            <a:endParaRPr lang="en-US" sz="1200" dirty="0"/>
-          </a:p>
-          <a:p>
-            <a:pPr marL="342900" indent="-342900">
-              <a:buSzPct val="100000"/>
-              <a:buChar char="•"/>
-            </a:pPr>
-            <a:r>
-              <a:rPr lang="en-US" sz="1200" dirty="0">
-                <a:solidFill>
-                  <a:srgbClr val="F1F5F9"/>
-                </a:solidFill>
-                <a:latin typeface="Arial" pitchFamily="34" charset="0"/>
-                <a:ea typeface="Arial" pitchFamily="34" charset="-122"/>
-                <a:cs typeface="Arial" pitchFamily="34" charset="-120"/>
-              </a:rPr>
               <a:t>Single integration (Trello only)</a:t>
             </a:r>
             <a:endParaRPr lang="en-US" sz="1200" dirty="0"/>
@@ -5197,8 +5119,8 @@
         </p:nvSpPr>
         <p:spPr>
           <a:xfrm>
-            <a:off x="4754880" y="914400"/>
-            <a:ext cx="3931920" cy="2560320"/>
+            <a:off x="4754880" y="1005840"/>
+            <a:ext cx="3931920" cy="1907177"/>
           </a:xfrm>
           <a:prstGeom prst="rect">
             <a:avLst/>
@@ -5208,6 +5130,13 @@
           </a:solidFill>
           <a:ln/>
         </p:spPr>
+        <p:txBody>
+          <a:bodyPr/>
+          <a:lstStyle/>
+          <a:p>
+            <a:endParaRPr lang="en-US"/>
+          </a:p>
+        </p:txBody>
       </p:sp>
       <p:sp>
         <p:nvSpPr>
@@ -5217,7 +5146,7 @@
         </p:nvSpPr>
         <p:spPr>
           <a:xfrm>
-            <a:off x="4937760" y="1005840"/>
+            <a:off x="4937760" y="1184366"/>
             <a:ext cx="3657600" cy="365760"/>
           </a:xfrm>
           <a:prstGeom prst="rect">
@@ -5230,7 +5159,7 @@
           <a:bodyPr wrap="square" rtlCol="0" anchor="ctr"/>
           <a:lstStyle/>
           <a:p>
-            <a:pPr indent="0" marL="0">
+            <a:pPr marL="0" indent="0">
               <a:buNone/>
             </a:pPr>
             <a:r>
@@ -5256,7 +5185,7 @@
         </p:nvSpPr>
         <p:spPr>
           <a:xfrm>
-            <a:off x="4937760" y="1463040"/>
+            <a:off x="4937760" y="1567543"/>
             <a:ext cx="3657600" cy="1828800"/>
           </a:xfrm>
           <a:prstGeom prst="rect">
@@ -5368,7 +5297,7 @@
         </p:nvSpPr>
         <p:spPr>
           <a:xfrm>
-            <a:off x="457200" y="3657600"/>
+            <a:off x="457200" y="3126378"/>
             <a:ext cx="2743200" cy="365760"/>
           </a:xfrm>
           <a:prstGeom prst="rect">
@@ -5381,7 +5310,7 @@
           <a:bodyPr wrap="square" rtlCol="0" anchor="ctr"/>
           <a:lstStyle/>
           <a:p>
-            <a:pPr indent="0" marL="0">
+            <a:pPr marL="0" indent="0">
               <a:buNone/>
             </a:pPr>
             <a:r>
@@ -5401,30 +5330,48 @@
       </p:sp>
       <p:graphicFrame>
         <p:nvGraphicFramePr>
-          <p:cNvPr id="6" name="Table 0"/>
+          <p:cNvPr id="10" name="Table 0"/>
           <p:cNvGraphicFramePr>
             <a:graphicFrameLocks noGrp="1"/>
           </p:cNvGraphicFramePr>
           <p:nvPr>
             <p:extLst>
               <p:ext uri="{D42A27DB-BD31-4B8C-83A1-F6EECF244321}">
-                <p14:modId xmlns:p14="http://schemas.microsoft.com/office/powerpoint/2010/main" val="1579011935"/>
+                <p14:modId xmlns:p14="http://schemas.microsoft.com/office/powerpoint/2010/main" val="2943232643"/>
               </p:ext>
             </p:extLst>
           </p:nvPr>
         </p:nvGraphicFramePr>
         <p:xfrm>
-          <a:off x="457200" y="4023360"/>
-          <a:ext cx="8229600" cy="1005840"/>
+          <a:off x="457200" y="3677739"/>
+          <a:ext cx="8229600" cy="1219200"/>
         </p:xfrm>
         <a:graphic>
           <a:graphicData uri="http://schemas.openxmlformats.org/drawingml/2006/table">
             <a:tbl>
               <a:tblPr/>
               <a:tblGrid>
-                <a:gridCol w="2743200"/>
-                <a:gridCol w="2743200"/>
-                <a:gridCol w="2743200"/>
+                <a:gridCol w="2743200">
+                  <a:extLst>
+                    <a:ext uri="{9D8B030D-6E8A-4147-A177-3AD203B41FA5}">
+                      <a16:colId xmlns:a16="http://schemas.microsoft.com/office/drawing/2014/main" val="20000"/>
+                    </a:ext>
+                  </a:extLst>
+                </a:gridCol>
+                <a:gridCol w="2743200">
+                  <a:extLst>
+                    <a:ext uri="{9D8B030D-6E8A-4147-A177-3AD203B41FA5}">
+                      <a16:colId xmlns:a16="http://schemas.microsoft.com/office/drawing/2014/main" val="20001"/>
+                    </a:ext>
+                  </a:extLst>
+                </a:gridCol>
+                <a:gridCol w="2743200">
+                  <a:extLst>
+                    <a:ext uri="{9D8B030D-6E8A-4147-A177-3AD203B41FA5}">
+                      <a16:colId xmlns:a16="http://schemas.microsoft.com/office/drawing/2014/main" val="20002"/>
+                    </a:ext>
+                  </a:extLst>
+                </a:gridCol>
               </a:tblGrid>
               <a:tr h="201168">
                 <a:tc>
@@ -5432,7 +5379,7 @@
                     <a:bodyPr/>
                     <a:lstStyle/>
                     <a:p>
-                      <a:pPr indent="0" marL="0">
+                      <a:pPr marL="0" indent="0">
                         <a:buNone/>
                       </a:pPr>
                       <a:r>
@@ -5453,7 +5400,7 @@
                       </a:endParaRPr>
                     </a:p>
                   </a:txBody>
-                  <a:tcPr marL="91440" marR="91440" marT="45720" marB="45720">
+                  <a:tcPr>
                     <a:lnL w="6350" cap="flat" cmpd="sng" algn="ctr">
                       <a:solidFill>
                         <a:srgbClr val="94A3B8"/>
@@ -5500,7 +5447,7 @@
                     <a:bodyPr/>
                     <a:lstStyle/>
                     <a:p>
-                      <a:pPr indent="0" marL="0">
+                      <a:pPr marL="0" indent="0">
                         <a:buNone/>
                       </a:pPr>
                       <a:r>
@@ -5521,7 +5468,7 @@
                       </a:endParaRPr>
                     </a:p>
                   </a:txBody>
-                  <a:tcPr marL="91440" marR="91440" marT="45720" marB="45720">
+                  <a:tcPr>
                     <a:lnL w="6350" cap="flat" cmpd="sng" algn="ctr">
                       <a:solidFill>
                         <a:srgbClr val="94A3B8"/>
@@ -5568,7 +5515,7 @@
                     <a:bodyPr/>
                     <a:lstStyle/>
                     <a:p>
-                      <a:pPr indent="0" marL="0">
+                      <a:pPr marL="0" indent="0">
                         <a:buNone/>
                       </a:pPr>
                       <a:r>
@@ -5589,7 +5536,7 @@
                       </a:endParaRPr>
                     </a:p>
                   </a:txBody>
-                  <a:tcPr marL="91440" marR="91440" marT="45720" marB="45720">
+                  <a:tcPr>
                     <a:lnL w="6350" cap="flat" cmpd="sng" algn="ctr">
                       <a:solidFill>
                         <a:srgbClr val="94A3B8"/>
@@ -5631,6 +5578,11 @@
                     </a:solidFill>
                   </a:tcPr>
                 </a:tc>
+                <a:extLst>
+                  <a:ext uri="{0D108BD9-81ED-4DB2-BD59-A6C34878D82A}">
+                    <a16:rowId xmlns:a16="http://schemas.microsoft.com/office/drawing/2014/main" val="10000"/>
+                  </a:ext>
+                </a:extLst>
               </a:tr>
               <a:tr h="201168">
                 <a:tc>
@@ -5638,7 +5590,7 @@
                     <a:bodyPr/>
                     <a:lstStyle/>
                     <a:p>
-                      <a:pPr indent="0" marL="0">
+                      <a:pPr marL="0" indent="0">
                         <a:buNone/>
                       </a:pPr>
                       <a:r>
@@ -5659,7 +5611,7 @@
                       </a:endParaRPr>
                     </a:p>
                   </a:txBody>
-                  <a:tcPr marL="91440" marR="91440" marT="45720" marB="45720">
+                  <a:tcPr>
                     <a:lnL w="6350" cap="flat" cmpd="sng" algn="ctr">
                       <a:solidFill>
                         <a:srgbClr val="94A3B8"/>
@@ -5706,7 +5658,7 @@
                     <a:bodyPr/>
                     <a:lstStyle/>
                     <a:p>
-                      <a:pPr indent="0" marL="0">
+                      <a:pPr marL="0" indent="0">
                         <a:buNone/>
                       </a:pPr>
                       <a:r>
@@ -5727,7 +5679,7 @@
                       </a:endParaRPr>
                     </a:p>
                   </a:txBody>
-                  <a:tcPr marL="91440" marR="91440" marT="45720" marB="45720">
+                  <a:tcPr>
                     <a:lnL w="6350" cap="flat" cmpd="sng" algn="ctr">
                       <a:solidFill>
                         <a:srgbClr val="94A3B8"/>
@@ -5774,7 +5726,7 @@
                     <a:bodyPr/>
                     <a:lstStyle/>
                     <a:p>
-                      <a:pPr indent="0" marL="0">
+                      <a:pPr marL="0" indent="0">
                         <a:buNone/>
                       </a:pPr>
                       <a:r>
@@ -5795,7 +5747,7 @@
                       </a:endParaRPr>
                     </a:p>
                   </a:txBody>
-                  <a:tcPr marL="91440" marR="91440" marT="45720" marB="45720">
+                  <a:tcPr>
                     <a:lnL w="6350" cap="flat" cmpd="sng" algn="ctr">
                       <a:solidFill>
                         <a:srgbClr val="94A3B8"/>
@@ -5837,6 +5789,11 @@
                     </a:solidFill>
                   </a:tcPr>
                 </a:tc>
+                <a:extLst>
+                  <a:ext uri="{0D108BD9-81ED-4DB2-BD59-A6C34878D82A}">
+                    <a16:rowId xmlns:a16="http://schemas.microsoft.com/office/drawing/2014/main" val="10001"/>
+                  </a:ext>
+                </a:extLst>
               </a:tr>
               <a:tr h="201168">
                 <a:tc>
@@ -5844,7 +5801,7 @@
                     <a:bodyPr/>
                     <a:lstStyle/>
                     <a:p>
-                      <a:pPr indent="0" marL="0">
+                      <a:pPr marL="0" indent="0">
                         <a:buNone/>
                       </a:pPr>
                       <a:r>
@@ -5865,7 +5822,7 @@
                       </a:endParaRPr>
                     </a:p>
                   </a:txBody>
-                  <a:tcPr marL="91440" marR="91440" marT="45720" marB="45720">
+                  <a:tcPr>
                     <a:lnL w="6350" cap="flat" cmpd="sng" algn="ctr">
                       <a:solidFill>
                         <a:srgbClr val="94A3B8"/>
@@ -5912,7 +5869,7 @@
                     <a:bodyPr/>
                     <a:lstStyle/>
                     <a:p>
-                      <a:pPr indent="0" marL="0">
+                      <a:pPr marL="0" indent="0">
                         <a:buNone/>
                       </a:pPr>
                       <a:r>
@@ -5933,7 +5890,7 @@
                       </a:endParaRPr>
                     </a:p>
                   </a:txBody>
-                  <a:tcPr marL="91440" marR="91440" marT="45720" marB="45720">
+                  <a:tcPr>
                     <a:lnL w="6350" cap="flat" cmpd="sng" algn="ctr">
                       <a:solidFill>
                         <a:srgbClr val="94A3B8"/>
@@ -5980,7 +5937,7 @@
                     <a:bodyPr/>
                     <a:lstStyle/>
                     <a:p>
-                      <a:pPr indent="0" marL="0">
+                      <a:pPr marL="0" indent="0">
                         <a:buNone/>
                       </a:pPr>
                       <a:r>
@@ -6001,7 +5958,7 @@
                       </a:endParaRPr>
                     </a:p>
                   </a:txBody>
-                  <a:tcPr marL="91440" marR="91440" marT="45720" marB="45720">
+                  <a:tcPr>
                     <a:lnL w="6350" cap="flat" cmpd="sng" algn="ctr">
                       <a:solidFill>
                         <a:srgbClr val="94A3B8"/>
@@ -6043,6 +6000,11 @@
                     </a:solidFill>
                   </a:tcPr>
                 </a:tc>
+                <a:extLst>
+                  <a:ext uri="{0D108BD9-81ED-4DB2-BD59-A6C34878D82A}">
+                    <a16:rowId xmlns:a16="http://schemas.microsoft.com/office/drawing/2014/main" val="10002"/>
+                  </a:ext>
+                </a:extLst>
               </a:tr>
               <a:tr h="201168">
                 <a:tc>
@@ -6050,7 +6012,7 @@
                     <a:bodyPr/>
                     <a:lstStyle/>
                     <a:p>
-                      <a:pPr indent="0" marL="0">
+                      <a:pPr marL="0" indent="0">
                         <a:buNone/>
                       </a:pPr>
                       <a:r>
@@ -6071,7 +6033,7 @@
                       </a:endParaRPr>
                     </a:p>
                   </a:txBody>
-                  <a:tcPr marL="91440" marR="91440" marT="45720" marB="45720">
+                  <a:tcPr>
                     <a:lnL w="6350" cap="flat" cmpd="sng" algn="ctr">
                       <a:solidFill>
                         <a:srgbClr val="94A3B8"/>
@@ -6118,7 +6080,7 @@
                     <a:bodyPr/>
                     <a:lstStyle/>
                     <a:p>
-                      <a:pPr indent="0" marL="0">
+                      <a:pPr marL="0" indent="0">
                         <a:buNone/>
                       </a:pPr>
                       <a:r>
@@ -6139,7 +6101,7 @@
                       </a:endParaRPr>
                     </a:p>
                   </a:txBody>
-                  <a:tcPr marL="91440" marR="91440" marT="45720" marB="45720">
+                  <a:tcPr>
                     <a:lnL w="6350" cap="flat" cmpd="sng" algn="ctr">
                       <a:solidFill>
                         <a:srgbClr val="94A3B8"/>
@@ -6186,7 +6148,7 @@
                     <a:bodyPr/>
                     <a:lstStyle/>
                     <a:p>
-                      <a:pPr indent="0" marL="0">
+                      <a:pPr marL="0" indent="0">
                         <a:buNone/>
                       </a:pPr>
                       <a:r>
@@ -6207,7 +6169,7 @@
                       </a:endParaRPr>
                     </a:p>
                   </a:txBody>
-                  <a:tcPr marL="91440" marR="91440" marT="45720" marB="45720">
+                  <a:tcPr>
                     <a:lnL w="6350" cap="flat" cmpd="sng" algn="ctr">
                       <a:solidFill>
                         <a:srgbClr val="94A3B8"/>
@@ -6249,6 +6211,11 @@
                     </a:solidFill>
                   </a:tcPr>
                 </a:tc>
+                <a:extLst>
+                  <a:ext uri="{0D108BD9-81ED-4DB2-BD59-A6C34878D82A}">
+                    <a16:rowId xmlns:a16="http://schemas.microsoft.com/office/drawing/2014/main" val="10003"/>
+                  </a:ext>
+                </a:extLst>
               </a:tr>
               <a:tr h="201168">
                 <a:tc>
@@ -6256,7 +6223,7 @@
                     <a:bodyPr/>
                     <a:lstStyle/>
                     <a:p>
-                      <a:pPr indent="0" marL="0">
+                      <a:pPr marL="0" indent="0">
                         <a:buNone/>
                       </a:pPr>
                       <a:r>
@@ -6277,7 +6244,7 @@
                       </a:endParaRPr>
                     </a:p>
                   </a:txBody>
-                  <a:tcPr marL="91440" marR="91440" marT="45720" marB="45720">
+                  <a:tcPr>
                     <a:lnL w="6350" cap="flat" cmpd="sng" algn="ctr">
                       <a:solidFill>
                         <a:srgbClr val="94A3B8"/>
@@ -6324,7 +6291,7 @@
                     <a:bodyPr/>
                     <a:lstStyle/>
                     <a:p>
-                      <a:pPr indent="0" marL="0">
+                      <a:pPr marL="0" indent="0">
                         <a:buNone/>
                       </a:pPr>
                       <a:r>
@@ -6345,7 +6312,7 @@
                       </a:endParaRPr>
                     </a:p>
                   </a:txBody>
-                  <a:tcPr marL="91440" marR="91440" marT="45720" marB="45720">
+                  <a:tcPr>
                     <a:lnL w="6350" cap="flat" cmpd="sng" algn="ctr">
                       <a:solidFill>
                         <a:srgbClr val="94A3B8"/>
@@ -6392,7 +6359,7 @@
                     <a:bodyPr/>
                     <a:lstStyle/>
                     <a:p>
-                      <a:pPr indent="0" marL="0">
+                      <a:pPr marL="0" indent="0">
                         <a:buNone/>
                       </a:pPr>
                       <a:r>
@@ -6413,7 +6380,7 @@
                       </a:endParaRPr>
                     </a:p>
                   </a:txBody>
-                  <a:tcPr marL="91440" marR="91440" marT="45720" marB="45720">
+                  <a:tcPr>
                     <a:lnL w="6350" cap="flat" cmpd="sng" algn="ctr">
                       <a:solidFill>
                         <a:srgbClr val="94A3B8"/>
@@ -6455,6 +6422,11 @@
                     </a:solidFill>
                   </a:tcPr>
                 </a:tc>
+                <a:extLst>
+                  <a:ext uri="{0D108BD9-81ED-4DB2-BD59-A6C34878D82A}">
+                    <a16:rowId xmlns:a16="http://schemas.microsoft.com/office/drawing/2014/main" val="10004"/>
+                  </a:ext>
+                </a:extLst>
               </a:tr>
             </a:tbl>
           </a:graphicData>
@@ -6761,4 +6733,319 @@
     </a:ext>
   </a:extLst>
 </a:theme>
+</file>
+
+<file path=ppt/theme/theme2.xml><?xml version="1.0" encoding="utf-8"?>
+<a:theme xmlns:a="http://schemas.openxmlformats.org/drawingml/2006/main" name="Office Theme">
+  <a:themeElements>
+    <a:clrScheme name="Office">
+      <a:dk1>
+        <a:sysClr val="windowText" lastClr="000000"/>
+      </a:dk1>
+      <a:lt1>
+        <a:sysClr val="window" lastClr="FFFFFF"/>
+      </a:lt1>
+      <a:dk2>
+        <a:srgbClr val="0E2841"/>
+      </a:dk2>
+      <a:lt2>
+        <a:srgbClr val="E8E8E8"/>
+      </a:lt2>
+      <a:accent1>
+        <a:srgbClr val="156082"/>
+      </a:accent1>
+      <a:accent2>
+        <a:srgbClr val="E97132"/>
+      </a:accent2>
+      <a:accent3>
+        <a:srgbClr val="196B24"/>
+      </a:accent3>
+      <a:accent4>
+        <a:srgbClr val="0F9ED5"/>
+      </a:accent4>
+      <a:accent5>
+        <a:srgbClr val="A02B93"/>
+      </a:accent5>
+      <a:accent6>
+        <a:srgbClr val="4EA72E"/>
+      </a:accent6>
+      <a:hlink>
+        <a:srgbClr val="467886"/>
+      </a:hlink>
+      <a:folHlink>
+        <a:srgbClr val="96607D"/>
+      </a:folHlink>
+    </a:clrScheme>
+    <a:fontScheme name="Office">
+      <a:majorFont>
+        <a:latin typeface="Aptos Display" panose="02110004020202020204"/>
+        <a:ea typeface=""/>
+        <a:cs typeface=""/>
+        <a:font script="Jpan" typeface="游ゴシック Light"/>
+        <a:font script="Hang" typeface="맑은 고딕"/>
+        <a:font script="Hans" typeface="等线 Light"/>
+        <a:font script="Hant" typeface="新細明體"/>
+        <a:font script="Arab" typeface="Times New Roman"/>
+        <a:font script="Hebr" typeface="Times New Roman"/>
+        <a:font script="Thai" typeface="Angsana New"/>
+        <a:font script="Ethi" typeface="Nyala"/>
+        <a:font script="Beng" typeface="Vrinda"/>
+        <a:font script="Gujr" typeface="Shruti"/>
+        <a:font script="Khmr" typeface="MoolBoran"/>
+        <a:font script="Knda" typeface="Tunga"/>
+        <a:font script="Guru" typeface="Raavi"/>
+        <a:font script="Cans" typeface="Euphemia"/>
+        <a:font script="Cher" typeface="Plantagenet Cherokee"/>
+        <a:font script="Yiii" typeface="Microsoft Yi Baiti"/>
+        <a:font script="Tibt" typeface="Microsoft Himalaya"/>
+        <a:font script="Thaa" typeface="MV Boli"/>
+        <a:font script="Deva" typeface="Mangal"/>
+        <a:font script="Telu" typeface="Gautami"/>
+        <a:font script="Taml" typeface="Latha"/>
+        <a:font script="Syrc" typeface="Estrangelo Edessa"/>
+        <a:font script="Orya" typeface="Kalinga"/>
+        <a:font script="Mlym" typeface="Kartika"/>
+        <a:font script="Laoo" typeface="DokChampa"/>
+        <a:font script="Sinh" typeface="Iskoola Pota"/>
+        <a:font script="Mong" typeface="Mongolian Baiti"/>
+        <a:font script="Viet" typeface="Times New Roman"/>
+        <a:font script="Uigh" typeface="Microsoft Uighur"/>
+        <a:font script="Geor" typeface="Sylfaen"/>
+        <a:font script="Armn" typeface="Arial"/>
+        <a:font script="Bugi" typeface="Leelawadee UI"/>
+        <a:font script="Bopo" typeface="Microsoft JhengHei"/>
+        <a:font script="Java" typeface="Javanese Text"/>
+        <a:font script="Lisu" typeface="Segoe UI"/>
+        <a:font script="Mymr" typeface="Myanmar Text"/>
+        <a:font script="Nkoo" typeface="Ebrima"/>
+        <a:font script="Olck" typeface="Nirmala UI"/>
+        <a:font script="Osma" typeface="Ebrima"/>
+        <a:font script="Phag" typeface="Phagspa"/>
+        <a:font script="Syrn" typeface="Estrangelo Edessa"/>
+        <a:font script="Syrj" typeface="Estrangelo Edessa"/>
+        <a:font script="Syre" typeface="Estrangelo Edessa"/>
+        <a:font script="Sora" typeface="Nirmala UI"/>
+        <a:font script="Tale" typeface="Microsoft Tai Le"/>
+        <a:font script="Talu" typeface="Microsoft New Tai Lue"/>
+        <a:font script="Tfng" typeface="Ebrima"/>
+      </a:majorFont>
+      <a:minorFont>
+        <a:latin typeface="Aptos" panose="02110004020202020204"/>
+        <a:ea typeface=""/>
+        <a:cs typeface=""/>
+        <a:font script="Jpan" typeface="游ゴシック"/>
+        <a:font script="Hang" typeface="맑은 고딕"/>
+        <a:font script="Hans" typeface="等线"/>
+        <a:font script="Hant" typeface="新細明體"/>
+        <a:font script="Arab" typeface="Arial"/>
+        <a:font script="Hebr" typeface="Arial"/>
+        <a:font script="Thai" typeface="Cordia New"/>
+        <a:font script="Ethi" typeface="Nyala"/>
+        <a:font script="Beng" typeface="Vrinda"/>
+        <a:font script="Gujr" typeface="Shruti"/>
+        <a:font script="Khmr" typeface="DaunPenh"/>
+        <a:font script="Knda" typeface="Tunga"/>
+        <a:font script="Guru" typeface="Raavi"/>
+        <a:font script="Cans" typeface="Euphemia"/>
+        <a:font script="Cher" typeface="Plantagenet Cherokee"/>
+        <a:font script="Yiii" typeface="Microsoft Yi Baiti"/>
+        <a:font script="Tibt" typeface="Microsoft Himalaya"/>
+        <a:font script="Thaa" typeface="MV Boli"/>
+        <a:font script="Deva" typeface="Mangal"/>
+        <a:font script="Telu" typeface="Gautami"/>
+        <a:font script="Taml" typeface="Latha"/>
+        <a:font script="Syrc" typeface="Estrangelo Edessa"/>
+        <a:font script="Orya" typeface="Kalinga"/>
+        <a:font script="Mlym" typeface="Kartika"/>
+        <a:font script="Laoo" typeface="DokChampa"/>
+        <a:font script="Sinh" typeface="Iskoola Pota"/>
+        <a:font script="Mong" typeface="Mongolian Baiti"/>
+        <a:font script="Viet" typeface="Arial"/>
+        <a:font script="Uigh" typeface="Microsoft Uighur"/>
+        <a:font script="Geor" typeface="Sylfaen"/>
+        <a:font script="Armn" typeface="Arial"/>
+        <a:font script="Bugi" typeface="Leelawadee UI"/>
+        <a:font script="Bopo" typeface="Microsoft JhengHei"/>
+        <a:font script="Java" typeface="Javanese Text"/>
+        <a:font script="Lisu" typeface="Segoe UI"/>
+        <a:font script="Mymr" typeface="Myanmar Text"/>
+        <a:font script="Nkoo" typeface="Ebrima"/>
+        <a:font script="Olck" typeface="Nirmala UI"/>
+        <a:font script="Osma" typeface="Ebrima"/>
+        <a:font script="Phag" typeface="Phagspa"/>
+        <a:font script="Syrn" typeface="Estrangelo Edessa"/>
+        <a:font script="Syrj" typeface="Estrangelo Edessa"/>
+        <a:font script="Syre" typeface="Estrangelo Edessa"/>
+        <a:font script="Sora" typeface="Nirmala UI"/>
+        <a:font script="Tale" typeface="Microsoft Tai Le"/>
+        <a:font script="Talu" typeface="Microsoft New Tai Lue"/>
+        <a:font script="Tfng" typeface="Ebrima"/>
+      </a:minorFont>
+    </a:fontScheme>
+    <a:fmtScheme name="Office">
+      <a:fillStyleLst>
+        <a:solidFill>
+          <a:schemeClr val="phClr"/>
+        </a:solidFill>
+        <a:gradFill rotWithShape="1">
+          <a:gsLst>
+            <a:gs pos="0">
+              <a:schemeClr val="phClr">
+                <a:lumMod val="110000"/>
+                <a:satMod val="105000"/>
+                <a:tint val="67000"/>
+              </a:schemeClr>
+            </a:gs>
+            <a:gs pos="50000">
+              <a:schemeClr val="phClr">
+                <a:lumMod val="105000"/>
+                <a:satMod val="103000"/>
+                <a:tint val="73000"/>
+              </a:schemeClr>
+            </a:gs>
+            <a:gs pos="100000">
+              <a:schemeClr val="phClr">
+                <a:lumMod val="105000"/>
+                <a:satMod val="109000"/>
+                <a:tint val="81000"/>
+              </a:schemeClr>
+            </a:gs>
+          </a:gsLst>
+          <a:lin ang="5400000" scaled="0"/>
+        </a:gradFill>
+        <a:gradFill rotWithShape="1">
+          <a:gsLst>
+            <a:gs pos="0">
+              <a:schemeClr val="phClr">
+                <a:satMod val="103000"/>
+                <a:lumMod val="102000"/>
+                <a:tint val="94000"/>
+              </a:schemeClr>
+            </a:gs>
+            <a:gs pos="50000">
+              <a:schemeClr val="phClr">
+                <a:satMod val="110000"/>
+                <a:lumMod val="100000"/>
+                <a:shade val="100000"/>
+              </a:schemeClr>
+            </a:gs>
+            <a:gs pos="100000">
+              <a:schemeClr val="phClr">
+                <a:lumMod val="99000"/>
+                <a:satMod val="120000"/>
+                <a:shade val="78000"/>
+              </a:schemeClr>
+            </a:gs>
+          </a:gsLst>
+          <a:lin ang="5400000" scaled="0"/>
+        </a:gradFill>
+      </a:fillStyleLst>
+      <a:lnStyleLst>
+        <a:ln w="12700" cap="flat" cmpd="sng" algn="ctr">
+          <a:solidFill>
+            <a:schemeClr val="phClr"/>
+          </a:solidFill>
+          <a:prstDash val="solid"/>
+          <a:miter lim="800000"/>
+        </a:ln>
+        <a:ln w="19050" cap="flat" cmpd="sng" algn="ctr">
+          <a:solidFill>
+            <a:schemeClr val="phClr"/>
+          </a:solidFill>
+          <a:prstDash val="solid"/>
+          <a:miter lim="800000"/>
+        </a:ln>
+        <a:ln w="25400" cap="flat" cmpd="sng" algn="ctr">
+          <a:solidFill>
+            <a:schemeClr val="phClr"/>
+          </a:solidFill>
+          <a:prstDash val="solid"/>
+          <a:miter lim="800000"/>
+        </a:ln>
+      </a:lnStyleLst>
+      <a:effectStyleLst>
+        <a:effectStyle>
+          <a:effectLst/>
+        </a:effectStyle>
+        <a:effectStyle>
+          <a:effectLst/>
+        </a:effectStyle>
+        <a:effectStyle>
+          <a:effectLst>
+            <a:outerShdw blurRad="57150" dist="19050" dir="5400000" algn="ctr" rotWithShape="0">
+              <a:srgbClr val="000000">
+                <a:alpha val="63000"/>
+              </a:srgbClr>
+            </a:outerShdw>
+          </a:effectLst>
+        </a:effectStyle>
+      </a:effectStyleLst>
+      <a:bgFillStyleLst>
+        <a:solidFill>
+          <a:schemeClr val="phClr"/>
+        </a:solidFill>
+        <a:solidFill>
+          <a:schemeClr val="phClr">
+            <a:tint val="95000"/>
+            <a:satMod val="170000"/>
+          </a:schemeClr>
+        </a:solidFill>
+        <a:gradFill rotWithShape="1">
+          <a:gsLst>
+            <a:gs pos="0">
+              <a:schemeClr val="phClr">
+                <a:tint val="93000"/>
+                <a:satMod val="150000"/>
+                <a:shade val="98000"/>
+                <a:lumMod val="102000"/>
+              </a:schemeClr>
+            </a:gs>
+            <a:gs pos="50000">
+              <a:schemeClr val="phClr">
+                <a:tint val="98000"/>
+                <a:satMod val="130000"/>
+                <a:shade val="90000"/>
+                <a:lumMod val="103000"/>
+              </a:schemeClr>
+            </a:gs>
+            <a:gs pos="100000">
+              <a:schemeClr val="phClr">
+                <a:shade val="63000"/>
+                <a:satMod val="120000"/>
+              </a:schemeClr>
+            </a:gs>
+          </a:gsLst>
+          <a:lin ang="5400000" scaled="0"/>
+        </a:gradFill>
+      </a:bgFillStyleLst>
+    </a:fmtScheme>
+  </a:themeElements>
+  <a:objectDefaults>
+    <a:lnDef>
+      <a:spPr/>
+      <a:bodyPr/>
+      <a:lstStyle/>
+      <a:style>
+        <a:lnRef idx="2">
+          <a:schemeClr val="accent1"/>
+        </a:lnRef>
+        <a:fillRef idx="0">
+          <a:schemeClr val="accent1"/>
+        </a:fillRef>
+        <a:effectRef idx="1">
+          <a:schemeClr val="accent1"/>
+        </a:effectRef>
+        <a:fontRef idx="minor">
+          <a:schemeClr val="tx1"/>
+        </a:fontRef>
+      </a:style>
+    </a:lnDef>
+  </a:objectDefaults>
+  <a:extraClrSchemeLst/>
+  <a:extLst>
+    <a:ext uri="{05A4C25C-085E-4340-85A3-A5531E510DB2}">
+      <thm15:themeFamily xmlns:thm15="http://schemas.microsoft.com/office/thememl/2012/main" name="Office Theme" id="{2E142A2C-CD16-42D6-873A-C26D2A0506FA}" vid="{1BDDFF52-6CD6-40A5-AB3C-68EB2F1E4D0A}"/>
+    </a:ext>
+  </a:extLst>
+</a:theme>
 </file>
</xml_diff>

<commit_message>
Add value proposition, fix tech stack references, update PPTX slides
- README: add value proposition (10-15 min saved per meeting)
- README: add data explanation (5-10 min recordings, sufficient for MVP)
- README: fix GPT-4o-mini → Groq LLM throughout, update cost table
- README: fix project structure comments (assemblyService.js added)
- PPTX slide 3: fix architecture flow GPT-4 → Groq
- PPTX slide 4: fix heading GPT-4o-mini → Groq LLM, fix cost trade-off text

Co-Authored-By: Claude Sonnet 4.6 <noreply@anthropic.com>
</commit_message>
<xml_diff>
--- a/docs/SyncBoard_MVP_Technical_Summary.pptx
+++ b/docs/SyncBoard_MVP_Technical_Summary.pptx
@@ -2219,7 +2219,7 @@
                 <a:ea typeface="Arial" pitchFamily="34" charset="-122"/>
                 <a:cs typeface="Arial" pitchFamily="34" charset="-120"/>
               </a:rPr>
-              <a:t>GPT-4</a:t>
+              <a:t>Groq</a:t>
             </a:r>
             <a:endParaRPr lang="en-US" sz="1100" dirty="0"/>
           </a:p>
@@ -4282,7 +4282,7 @@
                 <a:ea typeface="Arial" pitchFamily="34" charset="-122"/>
                 <a:cs typeface="Arial" pitchFamily="34" charset="-120"/>
               </a:rPr>
-              <a:t>GPT-4o-mini over Fine-tuning</a:t>
+              <a:t>Groq LLM over Fine-tuning</a:t>
             </a:r>
             <a:endParaRPr lang="en-US" sz="1300" dirty="0"/>
           </a:p>
@@ -4360,7 +4360,7 @@
                 <a:ea typeface="Arial" pitchFamily="34" charset="-122"/>
                 <a:cs typeface="Arial" pitchFamily="34" charset="-120"/>
               </a:rPr>
-              <a:t>↔ Higher per-request cost, but faster iteration</a:t>
+              <a:t>↔ Free tier (Groq), fast iteration without fine-tuning cost</a:t>
             </a:r>
             <a:endParaRPr lang="en-US" sz="900" dirty="0"/>
           </a:p>

</xml_diff>